<commit_message>
Add 30-day threshold outlook to buy/sell reasons
When the 30-day model shows >30% probability of hitting a threshold,
it appears as a reason in the recommendation. Example:
  Buy: "30-day model: 62% probability of reaching $80,000"

Short-term signals (TCN, RSI, order flow) still drive the primary
side, but now the 30-day outlook is visible in the reasoning.

Co-Authored-By: Claude Opus 4.6 (1M context) <noreply@anthropic.com>
</commit_message>
<xml_diff>
--- a/TrueMarkets_YC_Deck.pptx
+++ b/TrueMarkets_YC_Deck.pptx
@@ -4,6 +4,9 @@
   <p:sldMasterIdLst>
     <p:sldMasterId id="2147483648" r:id="rId1"/>
   </p:sldMasterIdLst>
+  <p:notesMasterIdLst>
+    <p:notesMasterId r:id="rId8"/>
+  </p:notesMasterIdLst>
   <p:sldIdLst>
     <p:sldId id="256" r:id="rId2"/>
     <p:sldId id="257" r:id="rId3"/>
@@ -12,10 +15,7 @@
     <p:sldId id="260" r:id="rId6"/>
     <p:sldId id="261" r:id="rId7"/>
   </p:sldIdLst>
-  <p:notesMasterIdLst>
-    <p:notesMasterId r:id="rId8"/>
-  </p:notesMasterIdLst>
-  <p:sldSz cx="9144000" cy="5143500"/>
+  <p:sldSz cx="9144000" cy="5143500" type="screen16x9"/>
   <p:notesSz cx="5143500" cy="9144000"/>
   <p:defaultTextStyle>
     <a:lvl1pPr marL="0" algn="l" defTabSz="914400" rtl="0" eaLnBrk="1" latinLnBrk="0" hangingPunct="1">
@@ -109,6 +109,11 @@
       </a:defRPr>
     </a:lvl9pPr>
   </p:defaultTextStyle>
+  <p:extLst>
+    <p:ext uri="{EFAFB233-063F-42B5-8137-9DF3F51BA10A}">
+      <p15:sldGuideLst xmlns:p15="http://schemas.microsoft.com/office/powerpoint/2012/main"/>
+    </p:ext>
+  </p:extLst>
 </p:presentation>
 </file>
 
@@ -134,234 +139,10 @@
           <a:chExt cx="0" cy="0"/>
         </a:xfrm>
       </p:grpSpPr>
-      <p:sp>
-        <p:nvSpPr>
-          <p:cNvPr id="2" name="Header Placeholder 1"/>
-          <p:cNvSpPr>
-            <a:spLocks noGrp="1"/>
-          </p:cNvSpPr>
-          <p:nvPr>
-            <p:ph type="hdr" sz="quarter"/>
-          </p:nvPr>
-        </p:nvSpPr>
-        <p:spPr>
-          <a:xfrm>
-            <a:off x="0" y="0"/>
-            <a:ext cx="2971800" cy="458788"/>
-          </a:xfrm>
-          <a:prstGeom prst="rect">
-            <a:avLst/>
-          </a:prstGeom>
-        </p:spPr>
-        <p:txBody>
-          <a:bodyPr vert="horz" lIns="91440" tIns="45720" rIns="91440" bIns="45720" rtlCol="0"/>
-          <a:lstStyle>
-            <a:lvl1pPr algn="l">
-              <a:defRPr sz="1200"/>
-            </a:lvl1pPr>
-          </a:lstStyle>
-          <a:p>
-            <a:endParaRPr lang="en-US"/>
-          </a:p>
-        </p:txBody>
-      </p:sp>
-      <p:sp>
-        <p:nvSpPr>
-          <p:cNvPr id="3" name="Date Placeholder 2"/>
-          <p:cNvSpPr>
-            <a:spLocks noGrp="1"/>
-          </p:cNvSpPr>
-          <p:nvPr>
-            <p:ph type="dt" idx="1"/>
-          </p:nvPr>
-        </p:nvSpPr>
-        <p:spPr>
-          <a:xfrm>
-            <a:off x="3884613" y="0"/>
-            <a:ext cx="2971800" cy="458788"/>
-          </a:xfrm>
-          <a:prstGeom prst="rect">
-            <a:avLst/>
-          </a:prstGeom>
-        </p:spPr>
-        <p:txBody>
-          <a:bodyPr vert="horz" lIns="91440" tIns="45720" rIns="91440" bIns="45720" rtlCol="0"/>
-          <a:lstStyle>
-            <a:lvl1pPr algn="r">
-              <a:defRPr sz="1200"/>
-            </a:lvl1pPr>
-          </a:lstStyle>
-          <a:p>
-            <a:fld id="{5282F153-3F37-0F45-9E97-73ACFA13230C}" type="datetimeFigureOut">
-              <a:rPr lang="en-US"/>
-              <a:t>7/23/19</a:t>
-            </a:fld>
-            <a:endParaRPr lang="en-US"/>
-          </a:p>
-        </p:txBody>
-      </p:sp>
-      <p:sp>
-        <p:nvSpPr>
-          <p:cNvPr id="4" name="Slide Image Placeholder 3"/>
-          <p:cNvSpPr>
-            <a:spLocks noGrp="1" noRot="1" noChangeAspect="1"/>
-          </p:cNvSpPr>
-          <p:nvPr>
-            <p:ph type="sldImg" idx="2"/>
-          </p:nvPr>
-        </p:nvSpPr>
-        <p:spPr>
-          <a:xfrm>
-            <a:off x="685800" y="1143000"/>
-            <a:ext cx="5486400" cy="3086100"/>
-          </a:xfrm>
-          <a:prstGeom prst="rect">
-            <a:avLst/>
-          </a:prstGeom>
-          <a:noFill/>
-          <a:ln w="12700">
-            <a:solidFill>
-              <a:prstClr val="black"/>
-            </a:solidFill>
-          </a:ln>
-        </p:spPr>
-        <p:txBody>
-          <a:bodyPr vert="horz" lIns="91440" tIns="45720" rIns="91440" bIns="45720" rtlCol="0" anchor="ctr"/>
-          <a:lstStyle/>
-          <a:p>
-            <a:endParaRPr lang="en-US"/>
-          </a:p>
-        </p:txBody>
-      </p:sp>
-      <p:sp>
-        <p:nvSpPr>
-          <p:cNvPr id="5" name="Notes Placeholder 4"/>
-          <p:cNvSpPr>
-            <a:spLocks noGrp="1"/>
-          </p:cNvSpPr>
-          <p:nvPr>
-            <p:ph type="body" sz="quarter" idx="3"/>
-          </p:nvPr>
-        </p:nvSpPr>
-        <p:spPr>
-          <a:xfrm>
-            <a:off x="685800" y="4400550"/>
-            <a:ext cx="5486400" cy="3600450"/>
-          </a:xfrm>
-          <a:prstGeom prst="rect">
-            <a:avLst/>
-          </a:prstGeom>
-        </p:spPr>
-        <p:txBody>
-          <a:bodyPr vert="horz" lIns="91440" tIns="45720" rIns="91440" bIns="45720" rtlCol="0"/>
-          <a:lstStyle/>
-          <a:p>
-            <a:pPr lvl="0"/>
-            <a:r>
-              <a:rPr lang="en-US"/>
-              <a:t>Click to edit Master text styles</a:t>
-            </a:r>
-          </a:p>
-          <a:p>
-            <a:pPr lvl="1"/>
-            <a:r>
-              <a:rPr lang="en-US"/>
-              <a:t>Second level</a:t>
-            </a:r>
-          </a:p>
-          <a:p>
-            <a:pPr lvl="2"/>
-            <a:r>
-              <a:rPr lang="en-US"/>
-              <a:t>Third level</a:t>
-            </a:r>
-          </a:p>
-          <a:p>
-            <a:pPr lvl="3"/>
-            <a:r>
-              <a:rPr lang="en-US"/>
-              <a:t>Fourth level</a:t>
-            </a:r>
-          </a:p>
-          <a:p>
-            <a:pPr lvl="4"/>
-            <a:r>
-              <a:rPr lang="en-US"/>
-              <a:t>Fifth level</a:t>
-            </a:r>
-          </a:p>
-        </p:txBody>
-      </p:sp>
-      <p:sp>
-        <p:nvSpPr>
-          <p:cNvPr id="6" name="Footer Placeholder 5"/>
-          <p:cNvSpPr>
-            <a:spLocks noGrp="1"/>
-          </p:cNvSpPr>
-          <p:nvPr>
-            <p:ph type="ftr" sz="quarter" idx="4"/>
-          </p:nvPr>
-        </p:nvSpPr>
-        <p:spPr>
-          <a:xfrm>
-            <a:off x="0" y="8685213"/>
-            <a:ext cx="2971800" cy="458787"/>
-          </a:xfrm>
-          <a:prstGeom prst="rect">
-            <a:avLst/>
-          </a:prstGeom>
-        </p:spPr>
-        <p:txBody>
-          <a:bodyPr vert="horz" lIns="91440" tIns="45720" rIns="91440" bIns="45720" rtlCol="0" anchor="b"/>
-          <a:lstStyle>
-            <a:lvl1pPr algn="l">
-              <a:defRPr sz="1200"/>
-            </a:lvl1pPr>
-          </a:lstStyle>
-          <a:p>
-            <a:endParaRPr lang="en-US"/>
-          </a:p>
-        </p:txBody>
-      </p:sp>
-      <p:sp>
-        <p:nvSpPr>
-          <p:cNvPr id="7" name="Slide Number Placeholder 6"/>
-          <p:cNvSpPr>
-            <a:spLocks noGrp="1"/>
-          </p:cNvSpPr>
-          <p:nvPr>
-            <p:ph type="sldNum" sz="quarter" idx="5"/>
-          </p:nvPr>
-        </p:nvSpPr>
-        <p:spPr>
-          <a:xfrm>
-            <a:off x="3884613" y="8685213"/>
-            <a:ext cx="2971800" cy="458787"/>
-          </a:xfrm>
-          <a:prstGeom prst="rect">
-            <a:avLst/>
-          </a:prstGeom>
-        </p:spPr>
-        <p:txBody>
-          <a:bodyPr vert="horz" lIns="91440" tIns="45720" rIns="91440" bIns="45720" rtlCol="0" anchor="b"/>
-          <a:lstStyle>
-            <a:lvl1pPr algn="r">
-              <a:defRPr sz="1200"/>
-            </a:lvl1pPr>
-          </a:lstStyle>
-          <a:p>
-            <a:fld id="{CE5E9CC1-C706-0F49-92D6-E571CC5EEA8F}" type="slidenum">
-              <a:rPr lang="en-US"/>
-              <a:t>‹#›</a:t>
-            </a:fld>
-            <a:endParaRPr lang="en-US"/>
-          </a:p>
-        </p:txBody>
-      </p:sp>
     </p:spTree>
     <p:extLst>
       <p:ext uri="{BB962C8B-B14F-4D97-AF65-F5344CB8AC3E}">
-        <p14:creationId xmlns:p14="http://schemas.microsoft.com/office/powerpoint/2010/main" val="1024086991"/>
+        <p14:creationId xmlns:p14="http://schemas.microsoft.com/office/powerpoint/2010/main" val="2483389817"/>
       </p:ext>
     </p:extLst>
   </p:cSld>
@@ -505,10 +286,6 @@
           <a:bodyPr/>
           <a:lstStyle/>
           <a:p>
-            <a:r>
-              <a:rPr lang="en-US" dirty="0"/>
-              <a:t/>
-            </a:r>
             <a:endParaRPr lang="en-US" dirty="0"/>
           </a:p>
         </p:txBody>
@@ -593,10 +370,6 @@
           <a:bodyPr/>
           <a:lstStyle/>
           <a:p>
-            <a:r>
-              <a:rPr lang="en-US" dirty="0"/>
-              <a:t/>
-            </a:r>
             <a:endParaRPr lang="en-US" dirty="0"/>
           </a:p>
         </p:txBody>
@@ -681,10 +454,6 @@
           <a:bodyPr/>
           <a:lstStyle/>
           <a:p>
-            <a:r>
-              <a:rPr lang="en-US" dirty="0"/>
-              <a:t/>
-            </a:r>
             <a:endParaRPr lang="en-US" dirty="0"/>
           </a:p>
         </p:txBody>
@@ -769,10 +538,6 @@
           <a:bodyPr/>
           <a:lstStyle/>
           <a:p>
-            <a:r>
-              <a:rPr lang="en-US" dirty="0"/>
-              <a:t/>
-            </a:r>
             <a:endParaRPr lang="en-US" dirty="0"/>
           </a:p>
         </p:txBody>
@@ -857,10 +622,6 @@
           <a:bodyPr/>
           <a:lstStyle/>
           <a:p>
-            <a:r>
-              <a:rPr lang="en-US" dirty="0"/>
-              <a:t/>
-            </a:r>
             <a:endParaRPr lang="en-US" dirty="0"/>
           </a:p>
         </p:txBody>
@@ -945,10 +706,6 @@
           <a:bodyPr/>
           <a:lstStyle/>
           <a:p>
-            <a:r>
-              <a:rPr lang="en-US" dirty="0"/>
-              <a:t/>
-            </a:r>
             <a:endParaRPr lang="en-US" dirty="0"/>
           </a:p>
         </p:txBody>
@@ -1022,6 +779,11 @@
 <file path=ppt/slideMasters/slideMaster1.xml><?xml version="1.0" encoding="utf-8"?>
 <p:sldMaster xmlns:a="http://schemas.openxmlformats.org/drawingml/2006/main" xmlns:r="http://schemas.openxmlformats.org/officeDocument/2006/relationships" xmlns:p="http://schemas.openxmlformats.org/presentationml/2006/main">
   <p:cSld>
+    <p:bg>
+      <p:bgRef idx="1001">
+        <a:schemeClr val="bg1"/>
+      </p:bgRef>
+    </p:bg>
     <p:spTree>
       <p:nvGrpSpPr>
         <p:cNvPr id="1" name=""/>
@@ -1304,6 +1066,7 @@
         <a:solidFill>
           <a:srgbClr val="0F0F1A"/>
         </a:solidFill>
+        <a:effectLst/>
       </p:bgPr>
     </p:bg>
     <p:spTree>
@@ -1383,7 +1146,7 @@
           <a:bodyPr wrap="square" lIns="0" tIns="0" rIns="0" bIns="0" rtlCol="0" anchor="ctr"/>
           <a:lstStyle/>
           <a:p>
-            <a:pPr indent="0" marL="0">
+            <a:pPr marL="0" indent="0">
               <a:buNone/>
             </a:pPr>
             <a:r>
@@ -1422,7 +1185,7 @@
           <a:bodyPr wrap="square" lIns="0" tIns="0" rIns="0" bIns="0" rtlCol="0" anchor="ctr"/>
           <a:lstStyle/>
           <a:p>
-            <a:pPr indent="0" marL="0">
+            <a:pPr marL="0" indent="0">
               <a:buNone/>
             </a:pPr>
             <a:r>
@@ -1483,7 +1246,7 @@
           <a:bodyPr wrap="square" lIns="0" tIns="0" rIns="0" bIns="0" rtlCol="0" anchor="ctr"/>
           <a:lstStyle/>
           <a:p>
-            <a:pPr indent="0" marL="0">
+            <a:pPr marL="0" indent="0">
               <a:buNone/>
             </a:pPr>
             <a:r>
@@ -1494,9 +1257,6 @@
               </a:rPr>
               <a:t>95%</a:t>
             </a:r>
-            <a:pPr indent="0" marL="0">
-              <a:buNone/>
-            </a:pPr>
             <a:r>
               <a:rPr lang="en-US" sz="1600" dirty="0">
                 <a:solidFill>
@@ -1530,7 +1290,7 @@
           <a:bodyPr wrap="square" lIns="0" tIns="0" rIns="0" bIns="0" rtlCol="0" anchor="ctr"/>
           <a:lstStyle/>
           <a:p>
-            <a:pPr indent="0" marL="0">
+            <a:pPr marL="0" indent="0">
               <a:buNone/>
             </a:pPr>
             <a:r>
@@ -1564,6 +1324,7 @@
         <a:solidFill>
           <a:srgbClr val="0F0F1A"/>
         </a:solidFill>
+        <a:effectLst/>
       </p:bgPr>
     </p:bg>
     <p:spTree>
@@ -1621,7 +1382,7 @@
           <a:bodyPr wrap="square" lIns="0" tIns="0" rIns="0" bIns="0" rtlCol="0" anchor="ctr"/>
           <a:lstStyle/>
           <a:p>
-            <a:pPr indent="0" marL="0">
+            <a:pPr marL="0" indent="0">
               <a:buNone/>
             </a:pPr>
             <a:r>
@@ -1660,7 +1421,7 @@
           <a:bodyPr wrap="square" lIns="0" tIns="0" rIns="0" bIns="0" rtlCol="0" anchor="ctr"/>
           <a:lstStyle/>
           <a:p>
-            <a:pPr algn="ctr" indent="0" marL="0">
+            <a:pPr marL="0" indent="0" algn="ctr">
               <a:buNone/>
             </a:pPr>
             <a:r>
@@ -1699,7 +1460,7 @@
           <a:bodyPr wrap="square" lIns="0" tIns="0" rIns="0" bIns="0" rtlCol="0" anchor="ctr"/>
           <a:lstStyle/>
           <a:p>
-            <a:pPr algn="ctr" indent="0" marL="0">
+            <a:pPr marL="0" indent="0" algn="ctr">
               <a:buNone/>
             </a:pPr>
             <a:r>
@@ -1713,7 +1474,7 @@
             <a:endParaRPr lang="en-US" sz="1400" dirty="0"/>
           </a:p>
           <a:p>
-            <a:pPr algn="ctr" indent="0" marL="0">
+            <a:pPr marL="0" indent="0" algn="ctr">
               <a:buNone/>
             </a:pPr>
             <a:r>
@@ -1750,285 +1511,7 @@
       </p:sp>
       <p:pic>
         <p:nvPicPr>
-          <p:cNvPr id="7" name="Image 0" descr="preencoded.png">    </p:cNvPr>
-          <p:cNvPicPr>
-            <a:picLocks noChangeAspect="1"/>
-          </p:cNvPicPr>
-          <p:nvPr/>
-        </p:nvPicPr>
-        <p:blipFill>
-          <a:blip r:embed="rId1"/>
-          <a:stretch>
-            <a:fillRect/>
-          </a:stretch>
-        </p:blipFill>
-        <p:spPr>
-          <a:xfrm>
-            <a:off x="960120" y="1325880"/>
-            <a:ext cx="457200" cy="457200"/>
-          </a:xfrm>
-          <a:prstGeom prst="rect">
-            <a:avLst/>
-          </a:prstGeom>
-        </p:spPr>
-      </p:pic>
-      <p:sp>
-        <p:nvSpPr>
-          <p:cNvPr id="8" name="Text 5"/>
-          <p:cNvSpPr/>
-          <p:nvPr/>
-        </p:nvSpPr>
-        <p:spPr>
-          <a:xfrm>
-            <a:off x="1600200" y="1188720"/>
-            <a:ext cx="3200400" cy="365760"/>
-          </a:xfrm>
-          <a:prstGeom prst="rect">
-            <a:avLst/>
-          </a:prstGeom>
-          <a:noFill/>
-          <a:ln/>
-        </p:spPr>
-        <p:txBody>
-          <a:bodyPr wrap="square" lIns="0" tIns="0" rIns="0" bIns="0" rtlCol="0" anchor="ctr"/>
-          <a:lstStyle/>
-          <a:p>
-            <a:pPr indent="0" marL="0">
-              <a:buNone/>
-            </a:pPr>
-            <a:r>
-              <a:rPr lang="en-US" sz="1600" b="1" dirty="0">
-                <a:solidFill>
-                  <a:srgbClr val="FFFFFF"/>
-                </a:solidFill>
-                <a:latin typeface="Calibri" pitchFamily="34" charset="0"/>
-                <a:ea typeface="Calibri" pitchFamily="34" charset="-122"/>
-                <a:cs typeface="Calibri" pitchFamily="34" charset="-120"/>
-              </a:rPr>
-              <a:t>Gut Feeling</a:t>
-            </a:r>
-            <a:endParaRPr lang="en-US" sz="1600" dirty="0"/>
-          </a:p>
-        </p:txBody>
-      </p:sp>
-      <p:sp>
-        <p:nvSpPr>
-          <p:cNvPr id="9" name="Text 6"/>
-          <p:cNvSpPr/>
-          <p:nvPr/>
-        </p:nvSpPr>
-        <p:spPr>
-          <a:xfrm>
-            <a:off x="1600200" y="1554480"/>
-            <a:ext cx="3657600" cy="457200"/>
-          </a:xfrm>
-          <a:prstGeom prst="rect">
-            <a:avLst/>
-          </a:prstGeom>
-          <a:noFill/>
-          <a:ln/>
-        </p:spPr>
-        <p:txBody>
-          <a:bodyPr wrap="square" lIns="0" tIns="0" rIns="0" bIns="0" rtlCol="0" anchor="ctr"/>
-          <a:lstStyle/>
-          <a:p>
-            <a:pPr indent="0" marL="0">
-              <a:buNone/>
-            </a:pPr>
-            <a:r>
-              <a:rPr lang="en-US" sz="1200" dirty="0">
-                <a:solidFill>
-                  <a:srgbClr val="8B8BA3"/>
-                </a:solidFill>
-                <a:latin typeface="Calibri" pitchFamily="34" charset="0"/>
-                <a:ea typeface="Calibri" pitchFamily="34" charset="-122"/>
-                <a:cs typeface="Calibri" pitchFamily="34" charset="-120"/>
-              </a:rPr>
-              <a:t>Traders rely on intuition</a:t>
-            </a:r>
-            <a:endParaRPr lang="en-US" sz="1200" dirty="0"/>
-          </a:p>
-          <a:p>
-            <a:pPr indent="0" marL="0">
-              <a:buNone/>
-            </a:pPr>
-            <a:r>
-              <a:rPr lang="en-US" sz="1200" dirty="0">
-                <a:solidFill>
-                  <a:srgbClr val="8B8BA3"/>
-                </a:solidFill>
-                <a:latin typeface="Calibri" pitchFamily="34" charset="0"/>
-                <a:ea typeface="Calibri" pitchFamily="34" charset="-122"/>
-                <a:cs typeface="Calibri" pitchFamily="34" charset="-120"/>
-              </a:rPr>
-              <a:t>and FOMO-driven decisions</a:t>
-            </a:r>
-            <a:endParaRPr lang="en-US" sz="1200" dirty="0"/>
-          </a:p>
-        </p:txBody>
-      </p:sp>
-      <p:sp>
-        <p:nvSpPr>
-          <p:cNvPr id="10" name="Shape 7"/>
-          <p:cNvSpPr/>
-          <p:nvPr/>
-        </p:nvSpPr>
-        <p:spPr>
-          <a:xfrm>
-            <a:off x="731520" y="2286000"/>
-            <a:ext cx="4754880" cy="1005840"/>
-          </a:xfrm>
-          <a:prstGeom prst="rect">
-            <a:avLst/>
-          </a:prstGeom>
-          <a:solidFill>
-            <a:srgbClr val="1E1E36"/>
-          </a:solidFill>
-          <a:ln/>
-        </p:spPr>
-      </p:sp>
-      <p:pic>
-        <p:nvPicPr>
-          <p:cNvPr id="11" name="Image 1" descr="preencoded.png">    </p:cNvPr>
-          <p:cNvPicPr>
-            <a:picLocks noChangeAspect="1"/>
-          </p:cNvPicPr>
-          <p:nvPr/>
-        </p:nvPicPr>
-        <p:blipFill>
-          <a:blip r:embed="rId2"/>
-          <a:stretch>
-            <a:fillRect/>
-          </a:stretch>
-        </p:blipFill>
-        <p:spPr>
-          <a:xfrm>
-            <a:off x="960120" y="2514600"/>
-            <a:ext cx="457200" cy="457200"/>
-          </a:xfrm>
-          <a:prstGeom prst="rect">
-            <a:avLst/>
-          </a:prstGeom>
-        </p:spPr>
-      </p:pic>
-      <p:sp>
-        <p:nvSpPr>
-          <p:cNvPr id="12" name="Text 8"/>
-          <p:cNvSpPr/>
-          <p:nvPr/>
-        </p:nvSpPr>
-        <p:spPr>
-          <a:xfrm>
-            <a:off x="1600200" y="2377440"/>
-            <a:ext cx="3200400" cy="365760"/>
-          </a:xfrm>
-          <a:prstGeom prst="rect">
-            <a:avLst/>
-          </a:prstGeom>
-          <a:noFill/>
-          <a:ln/>
-        </p:spPr>
-        <p:txBody>
-          <a:bodyPr wrap="square" lIns="0" tIns="0" rIns="0" bIns="0" rtlCol="0" anchor="ctr"/>
-          <a:lstStyle/>
-          <a:p>
-            <a:pPr indent="0" marL="0">
-              <a:buNone/>
-            </a:pPr>
-            <a:r>
-              <a:rPr lang="en-US" sz="1600" b="1" dirty="0">
-                <a:solidFill>
-                  <a:srgbClr val="FFFFFF"/>
-                </a:solidFill>
-                <a:latin typeface="Calibri" pitchFamily="34" charset="0"/>
-                <a:ea typeface="Calibri" pitchFamily="34" charset="-122"/>
-                <a:cs typeface="Calibri" pitchFamily="34" charset="-120"/>
-              </a:rPr>
-              <a:t>Twitter Alpha</a:t>
-            </a:r>
-            <a:endParaRPr lang="en-US" sz="1600" dirty="0"/>
-          </a:p>
-        </p:txBody>
-      </p:sp>
-      <p:sp>
-        <p:nvSpPr>
-          <p:cNvPr id="13" name="Text 9"/>
-          <p:cNvSpPr/>
-          <p:nvPr/>
-        </p:nvSpPr>
-        <p:spPr>
-          <a:xfrm>
-            <a:off x="1600200" y="2743200"/>
-            <a:ext cx="3657600" cy="457200"/>
-          </a:xfrm>
-          <a:prstGeom prst="rect">
-            <a:avLst/>
-          </a:prstGeom>
-          <a:noFill/>
-          <a:ln/>
-        </p:spPr>
-        <p:txBody>
-          <a:bodyPr wrap="square" lIns="0" tIns="0" rIns="0" bIns="0" rtlCol="0" anchor="ctr"/>
-          <a:lstStyle/>
-          <a:p>
-            <a:pPr indent="0" marL="0">
-              <a:buNone/>
-            </a:pPr>
-            <a:r>
-              <a:rPr lang="en-US" sz="1200" dirty="0">
-                <a:solidFill>
-                  <a:srgbClr val="8B8BA3"/>
-                </a:solidFill>
-                <a:latin typeface="Calibri" pitchFamily="34" charset="0"/>
-                <a:ea typeface="Calibri" pitchFamily="34" charset="-122"/>
-                <a:cs typeface="Calibri" pitchFamily="34" charset="-120"/>
-              </a:rPr>
-              <a:t>Following influencers with</a:t>
-            </a:r>
-            <a:endParaRPr lang="en-US" sz="1200" dirty="0"/>
-          </a:p>
-          <a:p>
-            <a:pPr indent="0" marL="0">
-              <a:buNone/>
-            </a:pPr>
-            <a:r>
-              <a:rPr lang="en-US" sz="1200" dirty="0">
-                <a:solidFill>
-                  <a:srgbClr val="8B8BA3"/>
-                </a:solidFill>
-                <a:latin typeface="Calibri" pitchFamily="34" charset="0"/>
-                <a:ea typeface="Calibri" pitchFamily="34" charset="-122"/>
-                <a:cs typeface="Calibri" pitchFamily="34" charset="-120"/>
-              </a:rPr>
-              <a:t>no track record or backtests</a:t>
-            </a:r>
-            <a:endParaRPr lang="en-US" sz="1200" dirty="0"/>
-          </a:p>
-        </p:txBody>
-      </p:sp>
-      <p:sp>
-        <p:nvSpPr>
-          <p:cNvPr id="14" name="Shape 10"/>
-          <p:cNvSpPr/>
-          <p:nvPr/>
-        </p:nvSpPr>
-        <p:spPr>
-          <a:xfrm>
-            <a:off x="731520" y="3474720"/>
-            <a:ext cx="4754880" cy="1005840"/>
-          </a:xfrm>
-          <a:prstGeom prst="rect">
-            <a:avLst/>
-          </a:prstGeom>
-          <a:solidFill>
-            <a:srgbClr val="1E1E36"/>
-          </a:solidFill>
-          <a:ln/>
-        </p:spPr>
-      </p:sp>
-      <p:pic>
-        <p:nvPicPr>
-          <p:cNvPr id="15" name="Image 2" descr="preencoded.png">    </p:cNvPr>
+          <p:cNvPr id="7" name="Image 0" descr="preencoded.png"/>
           <p:cNvPicPr>
             <a:picLocks noChangeAspect="1"/>
           </p:cNvPicPr>
@@ -2042,7 +1525,7 @@
         </p:blipFill>
         <p:spPr>
           <a:xfrm>
-            <a:off x="960120" y="3703320"/>
+            <a:off x="960120" y="1325880"/>
             <a:ext cx="457200" cy="457200"/>
           </a:xfrm>
           <a:prstGeom prst="rect">
@@ -2052,13 +1535,13 @@
       </p:pic>
       <p:sp>
         <p:nvSpPr>
-          <p:cNvPr id="16" name="Text 11"/>
-          <p:cNvSpPr/>
-          <p:nvPr/>
-        </p:nvSpPr>
-        <p:spPr>
-          <a:xfrm>
-            <a:off x="1600200" y="3566160"/>
+          <p:cNvPr id="8" name="Text 5"/>
+          <p:cNvSpPr/>
+          <p:nvPr/>
+        </p:nvSpPr>
+        <p:spPr>
+          <a:xfrm>
+            <a:off x="1600200" y="1188720"/>
             <a:ext cx="3200400" cy="365760"/>
           </a:xfrm>
           <a:prstGeom prst="rect">
@@ -2071,7 +1554,7 @@
           <a:bodyPr wrap="square" lIns="0" tIns="0" rIns="0" bIns="0" rtlCol="0" anchor="ctr"/>
           <a:lstStyle/>
           <a:p>
-            <a:pPr indent="0" marL="0">
+            <a:pPr marL="0" indent="0">
               <a:buNone/>
             </a:pPr>
             <a:r>
@@ -2083,7 +1566,7 @@
                 <a:ea typeface="Calibri" pitchFamily="34" charset="-122"/>
                 <a:cs typeface="Calibri" pitchFamily="34" charset="-120"/>
               </a:rPr>
-              <a:t>Single Indicators</a:t>
+              <a:t>Gut Feeling</a:t>
             </a:r>
             <a:endParaRPr lang="en-US" sz="1600" dirty="0"/>
           </a:p>
@@ -2091,13 +1574,13 @@
       </p:sp>
       <p:sp>
         <p:nvSpPr>
-          <p:cNvPr id="17" name="Text 12"/>
-          <p:cNvSpPr/>
-          <p:nvPr/>
-        </p:nvSpPr>
-        <p:spPr>
-          <a:xfrm>
-            <a:off x="1600200" y="3931920"/>
+          <p:cNvPr id="9" name="Text 6"/>
+          <p:cNvSpPr/>
+          <p:nvPr/>
+        </p:nvSpPr>
+        <p:spPr>
+          <a:xfrm>
+            <a:off x="1600200" y="1554480"/>
             <a:ext cx="3657600" cy="457200"/>
           </a:xfrm>
           <a:prstGeom prst="rect">
@@ -2110,7 +1593,7 @@
           <a:bodyPr wrap="square" lIns="0" tIns="0" rIns="0" bIns="0" rtlCol="0" anchor="ctr"/>
           <a:lstStyle/>
           <a:p>
-            <a:pPr indent="0" marL="0">
+            <a:pPr marL="0" indent="0">
               <a:buNone/>
             </a:pPr>
             <a:r>
@@ -2122,12 +1605,12 @@
                 <a:ea typeface="Calibri" pitchFamily="34" charset="-122"/>
                 <a:cs typeface="Calibri" pitchFamily="34" charset="-120"/>
               </a:rPr>
-              <a:t>RSI alone, MACD alone—</a:t>
+              <a:t>Traders rely on intuition</a:t>
             </a:r>
             <a:endParaRPr lang="en-US" sz="1200" dirty="0"/>
           </a:p>
           <a:p>
-            <a:pPr indent="0" marL="0">
+            <a:pPr marL="0" indent="0">
               <a:buNone/>
             </a:pPr>
             <a:r>
@@ -2139,7 +1622,7 @@
                 <a:ea typeface="Calibri" pitchFamily="34" charset="-122"/>
                 <a:cs typeface="Calibri" pitchFamily="34" charset="-120"/>
               </a:rPr>
-              <a:t>no multi-signal approach</a:t>
+              <a:t>and FOMO-driven decisions</a:t>
             </a:r>
             <a:endParaRPr lang="en-US" sz="1200" dirty="0"/>
           </a:p>
@@ -2147,43 +1630,321 @@
       </p:sp>
       <p:sp>
         <p:nvSpPr>
-          <p:cNvPr id="18" name="Text 13"/>
-          <p:cNvSpPr/>
-          <p:nvPr/>
-        </p:nvSpPr>
-        <p:spPr>
-          <a:xfrm>
-            <a:off x="731520" y="4389120"/>
-            <a:ext cx="7315200" cy="457200"/>
-          </a:xfrm>
-          <a:prstGeom prst="rect">
-            <a:avLst/>
-          </a:prstGeom>
-          <a:noFill/>
-          <a:ln/>
-        </p:spPr>
-        <p:txBody>
-          <a:bodyPr wrap="square" lIns="0" tIns="0" rIns="0" bIns="0" rtlCol="0" anchor="ctr"/>
-          <a:lstStyle/>
-          <a:p>
-            <a:pPr indent="0" marL="0">
-              <a:buNone/>
-            </a:pPr>
-            <a:r>
-              <a:rPr lang="en-US" sz="1400" i="1" dirty="0">
-                <a:solidFill>
-                  <a:srgbClr val="6B6B80"/>
+          <p:cNvPr id="10" name="Shape 7"/>
+          <p:cNvSpPr/>
+          <p:nvPr/>
+        </p:nvSpPr>
+        <p:spPr>
+          <a:xfrm>
+            <a:off x="731520" y="2286000"/>
+            <a:ext cx="4754880" cy="1005840"/>
+          </a:xfrm>
+          <a:prstGeom prst="rect">
+            <a:avLst/>
+          </a:prstGeom>
+          <a:solidFill>
+            <a:srgbClr val="1E1E36"/>
+          </a:solidFill>
+          <a:ln/>
+        </p:spPr>
+      </p:sp>
+      <p:pic>
+        <p:nvPicPr>
+          <p:cNvPr id="11" name="Image 1" descr="preencoded.png"/>
+          <p:cNvPicPr>
+            <a:picLocks noChangeAspect="1"/>
+          </p:cNvPicPr>
+          <p:nvPr/>
+        </p:nvPicPr>
+        <p:blipFill>
+          <a:blip r:embed="rId4"/>
+          <a:stretch>
+            <a:fillRect/>
+          </a:stretch>
+        </p:blipFill>
+        <p:spPr>
+          <a:xfrm>
+            <a:off x="960120" y="2514600"/>
+            <a:ext cx="457200" cy="457200"/>
+          </a:xfrm>
+          <a:prstGeom prst="rect">
+            <a:avLst/>
+          </a:prstGeom>
+        </p:spPr>
+      </p:pic>
+      <p:sp>
+        <p:nvSpPr>
+          <p:cNvPr id="12" name="Text 8"/>
+          <p:cNvSpPr/>
+          <p:nvPr/>
+        </p:nvSpPr>
+        <p:spPr>
+          <a:xfrm>
+            <a:off x="1600200" y="2377440"/>
+            <a:ext cx="3200400" cy="365760"/>
+          </a:xfrm>
+          <a:prstGeom prst="rect">
+            <a:avLst/>
+          </a:prstGeom>
+          <a:noFill/>
+          <a:ln/>
+        </p:spPr>
+        <p:txBody>
+          <a:bodyPr wrap="square" lIns="0" tIns="0" rIns="0" bIns="0" rtlCol="0" anchor="ctr"/>
+          <a:lstStyle/>
+          <a:p>
+            <a:pPr marL="0" indent="0">
+              <a:buNone/>
+            </a:pPr>
+            <a:r>
+              <a:rPr lang="en-US" sz="1600" b="1" dirty="0">
+                <a:solidFill>
+                  <a:srgbClr val="FFFFFF"/>
                 </a:solidFill>
                 <a:latin typeface="Calibri" pitchFamily="34" charset="0"/>
                 <a:ea typeface="Calibri" pitchFamily="34" charset="-122"/>
                 <a:cs typeface="Calibri" pitchFamily="34" charset="-120"/>
               </a:rPr>
+              <a:t>Twitter Alpha</a:t>
+            </a:r>
+            <a:endParaRPr lang="en-US" sz="1600" dirty="0"/>
+          </a:p>
+        </p:txBody>
+      </p:sp>
+      <p:sp>
+        <p:nvSpPr>
+          <p:cNvPr id="13" name="Text 9"/>
+          <p:cNvSpPr/>
+          <p:nvPr/>
+        </p:nvSpPr>
+        <p:spPr>
+          <a:xfrm>
+            <a:off x="1600200" y="2743200"/>
+            <a:ext cx="3657600" cy="457200"/>
+          </a:xfrm>
+          <a:prstGeom prst="rect">
+            <a:avLst/>
+          </a:prstGeom>
+          <a:noFill/>
+          <a:ln/>
+        </p:spPr>
+        <p:txBody>
+          <a:bodyPr wrap="square" lIns="0" tIns="0" rIns="0" bIns="0" rtlCol="0" anchor="ctr"/>
+          <a:lstStyle/>
+          <a:p>
+            <a:pPr marL="0" indent="0">
+              <a:buNone/>
+            </a:pPr>
+            <a:r>
+              <a:rPr lang="en-US" sz="1200" dirty="0">
+                <a:solidFill>
+                  <a:srgbClr val="8B8BA3"/>
+                </a:solidFill>
+                <a:latin typeface="Calibri" pitchFamily="34" charset="0"/>
+                <a:ea typeface="Calibri" pitchFamily="34" charset="-122"/>
+                <a:cs typeface="Calibri" pitchFamily="34" charset="-120"/>
+              </a:rPr>
+              <a:t>Following influencers with</a:t>
+            </a:r>
+            <a:endParaRPr lang="en-US" sz="1200" dirty="0"/>
+          </a:p>
+          <a:p>
+            <a:pPr marL="0" indent="0">
+              <a:buNone/>
+            </a:pPr>
+            <a:r>
+              <a:rPr lang="en-US" sz="1200" dirty="0">
+                <a:solidFill>
+                  <a:srgbClr val="8B8BA3"/>
+                </a:solidFill>
+                <a:latin typeface="Calibri" pitchFamily="34" charset="0"/>
+                <a:ea typeface="Calibri" pitchFamily="34" charset="-122"/>
+                <a:cs typeface="Calibri" pitchFamily="34" charset="-120"/>
+              </a:rPr>
+              <a:t>no track record or backtests</a:t>
+            </a:r>
+            <a:endParaRPr lang="en-US" sz="1200" dirty="0"/>
+          </a:p>
+        </p:txBody>
+      </p:sp>
+      <p:sp>
+        <p:nvSpPr>
+          <p:cNvPr id="14" name="Shape 10"/>
+          <p:cNvSpPr/>
+          <p:nvPr/>
+        </p:nvSpPr>
+        <p:spPr>
+          <a:xfrm>
+            <a:off x="731520" y="3474720"/>
+            <a:ext cx="4754880" cy="1005840"/>
+          </a:xfrm>
+          <a:prstGeom prst="rect">
+            <a:avLst/>
+          </a:prstGeom>
+          <a:solidFill>
+            <a:srgbClr val="1E1E36"/>
+          </a:solidFill>
+          <a:ln/>
+        </p:spPr>
+      </p:sp>
+      <p:pic>
+        <p:nvPicPr>
+          <p:cNvPr id="15" name="Image 2" descr="preencoded.png"/>
+          <p:cNvPicPr>
+            <a:picLocks noChangeAspect="1"/>
+          </p:cNvPicPr>
+          <p:nvPr/>
+        </p:nvPicPr>
+        <p:blipFill>
+          <a:blip r:embed="rId5"/>
+          <a:stretch>
+            <a:fillRect/>
+          </a:stretch>
+        </p:blipFill>
+        <p:spPr>
+          <a:xfrm>
+            <a:off x="960120" y="3703320"/>
+            <a:ext cx="457200" cy="457200"/>
+          </a:xfrm>
+          <a:prstGeom prst="rect">
+            <a:avLst/>
+          </a:prstGeom>
+        </p:spPr>
+      </p:pic>
+      <p:sp>
+        <p:nvSpPr>
+          <p:cNvPr id="16" name="Text 11"/>
+          <p:cNvSpPr/>
+          <p:nvPr/>
+        </p:nvSpPr>
+        <p:spPr>
+          <a:xfrm>
+            <a:off x="1600200" y="3566160"/>
+            <a:ext cx="3200400" cy="365760"/>
+          </a:xfrm>
+          <a:prstGeom prst="rect">
+            <a:avLst/>
+          </a:prstGeom>
+          <a:noFill/>
+          <a:ln/>
+        </p:spPr>
+        <p:txBody>
+          <a:bodyPr wrap="square" lIns="0" tIns="0" rIns="0" bIns="0" rtlCol="0" anchor="ctr"/>
+          <a:lstStyle/>
+          <a:p>
+            <a:pPr marL="0" indent="0">
+              <a:buNone/>
+            </a:pPr>
+            <a:r>
+              <a:rPr lang="en-US" sz="1600" b="1" dirty="0">
+                <a:solidFill>
+                  <a:srgbClr val="FFFFFF"/>
+                </a:solidFill>
+                <a:latin typeface="Calibri" pitchFamily="34" charset="0"/>
+                <a:ea typeface="Calibri" pitchFamily="34" charset="-122"/>
+                <a:cs typeface="Calibri" pitchFamily="34" charset="-120"/>
+              </a:rPr>
+              <a:t>Single Indicators</a:t>
+            </a:r>
+            <a:endParaRPr lang="en-US" sz="1600" dirty="0"/>
+          </a:p>
+        </p:txBody>
+      </p:sp>
+      <p:sp>
+        <p:nvSpPr>
+          <p:cNvPr id="17" name="Text 12"/>
+          <p:cNvSpPr/>
+          <p:nvPr/>
+        </p:nvSpPr>
+        <p:spPr>
+          <a:xfrm>
+            <a:off x="1600200" y="3931920"/>
+            <a:ext cx="3657600" cy="457200"/>
+          </a:xfrm>
+          <a:prstGeom prst="rect">
+            <a:avLst/>
+          </a:prstGeom>
+          <a:noFill/>
+          <a:ln/>
+        </p:spPr>
+        <p:txBody>
+          <a:bodyPr wrap="square" lIns="0" tIns="0" rIns="0" bIns="0" rtlCol="0" anchor="ctr"/>
+          <a:lstStyle/>
+          <a:p>
+            <a:pPr marL="0" indent="0">
+              <a:buNone/>
+            </a:pPr>
+            <a:r>
+              <a:rPr lang="en-US" sz="1200" dirty="0">
+                <a:solidFill>
+                  <a:srgbClr val="8B8BA3"/>
+                </a:solidFill>
+                <a:latin typeface="Calibri" pitchFamily="34" charset="0"/>
+                <a:ea typeface="Calibri" pitchFamily="34" charset="-122"/>
+                <a:cs typeface="Calibri" pitchFamily="34" charset="-120"/>
+              </a:rPr>
+              <a:t>RSI alone, MACD alone—</a:t>
+            </a:r>
+            <a:endParaRPr lang="en-US" sz="1200" dirty="0"/>
+          </a:p>
+          <a:p>
+            <a:pPr marL="0" indent="0">
+              <a:buNone/>
+            </a:pPr>
+            <a:r>
+              <a:rPr lang="en-US" sz="1200" dirty="0">
+                <a:solidFill>
+                  <a:srgbClr val="8B8BA3"/>
+                </a:solidFill>
+                <a:latin typeface="Calibri" pitchFamily="34" charset="0"/>
+                <a:ea typeface="Calibri" pitchFamily="34" charset="-122"/>
+                <a:cs typeface="Calibri" pitchFamily="34" charset="-120"/>
+              </a:rPr>
+              <a:t>no multi-signal approach</a:t>
+            </a:r>
+            <a:endParaRPr lang="en-US" sz="1200" dirty="0"/>
+          </a:p>
+        </p:txBody>
+      </p:sp>
+      <p:sp>
+        <p:nvSpPr>
+          <p:cNvPr id="18" name="Text 13"/>
+          <p:cNvSpPr/>
+          <p:nvPr/>
+        </p:nvSpPr>
+        <p:spPr>
+          <a:xfrm>
+            <a:off x="731520" y="4389120"/>
+            <a:ext cx="7315200" cy="457200"/>
+          </a:xfrm>
+          <a:prstGeom prst="rect">
+            <a:avLst/>
+          </a:prstGeom>
+          <a:noFill/>
+          <a:ln/>
+        </p:spPr>
+        <p:txBody>
+          <a:bodyPr wrap="square" lIns="0" tIns="0" rIns="0" bIns="0" rtlCol="0" anchor="ctr"/>
+          <a:lstStyle/>
+          <a:p>
+            <a:pPr marL="0" indent="0">
+              <a:buNone/>
+            </a:pPr>
+            <a:r>
+              <a:rPr lang="en-US" sz="1400" i="1" dirty="0">
+                <a:solidFill>
+                  <a:srgbClr val="6B6B80"/>
+                </a:solidFill>
+                <a:latin typeface="Calibri" pitchFamily="34" charset="0"/>
+                <a:ea typeface="Calibri" pitchFamily="34" charset="-122"/>
+                <a:cs typeface="Calibri" pitchFamily="34" charset="-120"/>
+              </a:rPr>
               <a:t>Current tools show data.</a:t>
             </a:r>
             <a:endParaRPr lang="en-US" sz="1400" dirty="0"/>
           </a:p>
           <a:p>
-            <a:pPr indent="0" marL="0">
+            <a:pPr marL="0" indent="0">
               <a:buNone/>
             </a:pPr>
             <a:r>
@@ -2217,6 +1978,7 @@
         <a:solidFill>
           <a:srgbClr val="0F0F1A"/>
         </a:solidFill>
+        <a:effectLst/>
       </p:bgPr>
     </p:bg>
     <p:spTree>
@@ -2274,7 +2036,7 @@
           <a:bodyPr wrap="square" lIns="0" tIns="0" rIns="0" bIns="0" rtlCol="0" anchor="ctr"/>
           <a:lstStyle/>
           <a:p>
-            <a:pPr indent="0" marL="0">
+            <a:pPr marL="0" indent="0">
               <a:buNone/>
             </a:pPr>
             <a:r>
@@ -2313,7 +2075,7 @@
           <a:bodyPr wrap="square" lIns="0" tIns="0" rIns="0" bIns="0" rtlCol="0" anchor="ctr"/>
           <a:lstStyle/>
           <a:p>
-            <a:pPr indent="0" marL="0">
+            <a:pPr marL="0" indent="0">
               <a:buNone/>
             </a:pPr>
             <a:r>
@@ -2373,329 +2135,7 @@
       </p:sp>
       <p:pic>
         <p:nvPicPr>
-          <p:cNvPr id="7" name="Image 0" descr="preencoded.png">    </p:cNvPr>
-          <p:cNvPicPr>
-            <a:picLocks noChangeAspect="1"/>
-          </p:cNvPicPr>
-          <p:nvPr/>
-        </p:nvPicPr>
-        <p:blipFill>
-          <a:blip r:embed="rId1"/>
-          <a:stretch>
-            <a:fillRect/>
-          </a:stretch>
-        </p:blipFill>
-        <p:spPr>
-          <a:xfrm>
-            <a:off x="1005840" y="1691640"/>
-            <a:ext cx="502920" cy="502920"/>
-          </a:xfrm>
-          <a:prstGeom prst="rect">
-            <a:avLst/>
-          </a:prstGeom>
-        </p:spPr>
-      </p:pic>
-      <p:sp>
-        <p:nvSpPr>
-          <p:cNvPr id="8" name="Text 5"/>
-          <p:cNvSpPr/>
-          <p:nvPr/>
-        </p:nvSpPr>
-        <p:spPr>
-          <a:xfrm>
-            <a:off x="1645920" y="1508760"/>
-            <a:ext cx="2743200" cy="411480"/>
-          </a:xfrm>
-          <a:prstGeom prst="rect">
-            <a:avLst/>
-          </a:prstGeom>
-          <a:noFill/>
-          <a:ln/>
-        </p:spPr>
-        <p:txBody>
-          <a:bodyPr wrap="square" lIns="0" tIns="0" rIns="0" bIns="0" rtlCol="0" anchor="ctr"/>
-          <a:lstStyle/>
-          <a:p>
-            <a:pPr indent="0" marL="0">
-              <a:buNone/>
-            </a:pPr>
-            <a:r>
-              <a:rPr lang="en-US" sz="1600" b="1" dirty="0">
-                <a:solidFill>
-                  <a:srgbClr val="FFFFFF"/>
-                </a:solidFill>
-              </a:rPr>
-              <a:t>Technical</a:t>
-            </a:r>
-            <a:pPr indent="0" marL="0">
-              <a:buNone/>
-            </a:pPr>
-            <a:r>
-              <a:rPr lang="en-US" sz="2000" b="1" dirty="0">
-                <a:solidFill>
-                  <a:srgbClr val="FFE66D"/>
-                </a:solidFill>
-              </a:rPr>
-              <a:t>  40%</a:t>
-            </a:r>
-            <a:endParaRPr lang="en-US" sz="1600" dirty="0"/>
-          </a:p>
-        </p:txBody>
-      </p:sp>
-      <p:sp>
-        <p:nvSpPr>
-          <p:cNvPr id="9" name="Text 6"/>
-          <p:cNvSpPr/>
-          <p:nvPr/>
-        </p:nvSpPr>
-        <p:spPr>
-          <a:xfrm>
-            <a:off x="1645920" y="1965960"/>
-            <a:ext cx="2743200" cy="548640"/>
-          </a:xfrm>
-          <a:prstGeom prst="rect">
-            <a:avLst/>
-          </a:prstGeom>
-          <a:noFill/>
-          <a:ln/>
-        </p:spPr>
-        <p:txBody>
-          <a:bodyPr wrap="square" lIns="0" tIns="0" rIns="0" bIns="0" rtlCol="0" anchor="ctr"/>
-          <a:lstStyle/>
-          <a:p>
-            <a:pPr indent="0" marL="0">
-              <a:buNone/>
-            </a:pPr>
-            <a:r>
-              <a:rPr lang="en-US" sz="1100" dirty="0">
-                <a:solidFill>
-                  <a:srgbClr val="8B8BA3"/>
-                </a:solidFill>
-              </a:rPr>
-              <a:t>RSI mean-reversion at extremes</a:t>
-            </a:r>
-            <a:endParaRPr lang="en-US" sz="1100" dirty="0"/>
-          </a:p>
-          <a:p>
-            <a:pPr indent="0" marL="0">
-              <a:buNone/>
-            </a:pPr>
-            <a:r>
-              <a:rPr lang="en-US" sz="1100" dirty="0">
-                <a:solidFill>
-                  <a:srgbClr val="8B8BA3"/>
-                </a:solidFill>
-              </a:rPr>
-              <a:t>MACD trend direction</a:t>
-            </a:r>
-            <a:endParaRPr lang="en-US" sz="1100" dirty="0"/>
-          </a:p>
-        </p:txBody>
-      </p:sp>
-      <p:sp>
-        <p:nvSpPr>
-          <p:cNvPr id="10" name="Shape 7"/>
-          <p:cNvSpPr/>
-          <p:nvPr/>
-        </p:nvSpPr>
-        <p:spPr>
-          <a:xfrm>
-            <a:off x="4754880" y="1371600"/>
-            <a:ext cx="3840480" cy="1280160"/>
-          </a:xfrm>
-          <a:prstGeom prst="rect">
-            <a:avLst/>
-          </a:prstGeom>
-          <a:solidFill>
-            <a:srgbClr val="1E1E36"/>
-          </a:solidFill>
-          <a:ln/>
-        </p:spPr>
-      </p:sp>
-      <p:sp>
-        <p:nvSpPr>
-          <p:cNvPr id="11" name="Shape 8"/>
-          <p:cNvSpPr/>
-          <p:nvPr/>
-        </p:nvSpPr>
-        <p:spPr>
-          <a:xfrm>
-            <a:off x="4754880" y="1371600"/>
-            <a:ext cx="54864" cy="1280160"/>
-          </a:xfrm>
-          <a:prstGeom prst="rect">
-            <a:avLst/>
-          </a:prstGeom>
-          <a:solidFill>
-            <a:srgbClr val="00D4AA"/>
-          </a:solidFill>
-          <a:ln/>
-        </p:spPr>
-      </p:sp>
-      <p:pic>
-        <p:nvPicPr>
-          <p:cNvPr id="12" name="Image 1" descr="preencoded.png">    </p:cNvPr>
-          <p:cNvPicPr>
-            <a:picLocks noChangeAspect="1"/>
-          </p:cNvPicPr>
-          <p:nvPr/>
-        </p:nvPicPr>
-        <p:blipFill>
-          <a:blip r:embed="rId2"/>
-          <a:stretch>
-            <a:fillRect/>
-          </a:stretch>
-        </p:blipFill>
-        <p:spPr>
-          <a:xfrm>
-            <a:off x="5029200" y="1691640"/>
-            <a:ext cx="502920" cy="502920"/>
-          </a:xfrm>
-          <a:prstGeom prst="rect">
-            <a:avLst/>
-          </a:prstGeom>
-        </p:spPr>
-      </p:pic>
-      <p:sp>
-        <p:nvSpPr>
-          <p:cNvPr id="13" name="Text 9"/>
-          <p:cNvSpPr/>
-          <p:nvPr/>
-        </p:nvSpPr>
-        <p:spPr>
-          <a:xfrm>
-            <a:off x="5669280" y="1508760"/>
-            <a:ext cx="2743200" cy="411480"/>
-          </a:xfrm>
-          <a:prstGeom prst="rect">
-            <a:avLst/>
-          </a:prstGeom>
-          <a:noFill/>
-          <a:ln/>
-        </p:spPr>
-        <p:txBody>
-          <a:bodyPr wrap="square" lIns="0" tIns="0" rIns="0" bIns="0" rtlCol="0" anchor="ctr"/>
-          <a:lstStyle/>
-          <a:p>
-            <a:pPr indent="0" marL="0">
-              <a:buNone/>
-            </a:pPr>
-            <a:r>
-              <a:rPr lang="en-US" sz="1600" b="1" dirty="0">
-                <a:solidFill>
-                  <a:srgbClr val="FFFFFF"/>
-                </a:solidFill>
-              </a:rPr>
-              <a:t>TCN Model</a:t>
-            </a:r>
-            <a:pPr indent="0" marL="0">
-              <a:buNone/>
-            </a:pPr>
-            <a:r>
-              <a:rPr lang="en-US" sz="2000" b="1" dirty="0">
-                <a:solidFill>
-                  <a:srgbClr val="00D4AA"/>
-                </a:solidFill>
-              </a:rPr>
-              <a:t>  30%</a:t>
-            </a:r>
-            <a:endParaRPr lang="en-US" sz="1600" dirty="0"/>
-          </a:p>
-        </p:txBody>
-      </p:sp>
-      <p:sp>
-        <p:nvSpPr>
-          <p:cNvPr id="14" name="Text 10"/>
-          <p:cNvSpPr/>
-          <p:nvPr/>
-        </p:nvSpPr>
-        <p:spPr>
-          <a:xfrm>
-            <a:off x="5669280" y="1965960"/>
-            <a:ext cx="2743200" cy="548640"/>
-          </a:xfrm>
-          <a:prstGeom prst="rect">
-            <a:avLst/>
-          </a:prstGeom>
-          <a:noFill/>
-          <a:ln/>
-        </p:spPr>
-        <p:txBody>
-          <a:bodyPr wrap="square" lIns="0" tIns="0" rIns="0" bIns="0" rtlCol="0" anchor="ctr"/>
-          <a:lstStyle/>
-          <a:p>
-            <a:pPr indent="0" marL="0">
-              <a:buNone/>
-            </a:pPr>
-            <a:r>
-              <a:rPr lang="en-US" sz="1100" dirty="0">
-                <a:solidFill>
-                  <a:srgbClr val="8B8BA3"/>
-                </a:solidFill>
-              </a:rPr>
-              <a:t>Temporal Convolutional Network</a:t>
-            </a:r>
-            <a:endParaRPr lang="en-US" sz="1100" dirty="0"/>
-          </a:p>
-          <a:p>
-            <a:pPr indent="0" marL="0">
-              <a:buNone/>
-            </a:pPr>
-            <a:r>
-              <a:rPr lang="en-US" sz="1100" dirty="0">
-                <a:solidFill>
-                  <a:srgbClr val="8B8BA3"/>
-                </a:solidFill>
-              </a:rPr>
-              <a:t>3 years of BTC training data</a:t>
-            </a:r>
-            <a:endParaRPr lang="en-US" sz="1100" dirty="0"/>
-          </a:p>
-        </p:txBody>
-      </p:sp>
-      <p:sp>
-        <p:nvSpPr>
-          <p:cNvPr id="15" name="Shape 11"/>
-          <p:cNvSpPr/>
-          <p:nvPr/>
-        </p:nvSpPr>
-        <p:spPr>
-          <a:xfrm>
-            <a:off x="731520" y="2926080"/>
-            <a:ext cx="3840480" cy="1280160"/>
-          </a:xfrm>
-          <a:prstGeom prst="rect">
-            <a:avLst/>
-          </a:prstGeom>
-          <a:solidFill>
-            <a:srgbClr val="1E1E36"/>
-          </a:solidFill>
-          <a:ln/>
-        </p:spPr>
-      </p:sp>
-      <p:sp>
-        <p:nvSpPr>
-          <p:cNvPr id="16" name="Shape 12"/>
-          <p:cNvSpPr/>
-          <p:nvPr/>
-        </p:nvSpPr>
-        <p:spPr>
-          <a:xfrm>
-            <a:off x="731520" y="2926080"/>
-            <a:ext cx="54864" cy="1280160"/>
-          </a:xfrm>
-          <a:prstGeom prst="rect">
-            <a:avLst/>
-          </a:prstGeom>
-          <a:solidFill>
-            <a:srgbClr val="A29BFE"/>
-          </a:solidFill>
-          <a:ln/>
-        </p:spPr>
-      </p:sp>
-      <p:pic>
-        <p:nvPicPr>
-          <p:cNvPr id="17" name="Image 2" descr="preencoded.png">    </p:cNvPr>
+          <p:cNvPr id="7" name="Image 0" descr="preencoded.png"/>
           <p:cNvPicPr>
             <a:picLocks noChangeAspect="1"/>
           </p:cNvPicPr>
@@ -2709,7 +2149,7 @@
         </p:blipFill>
         <p:spPr>
           <a:xfrm>
-            <a:off x="1005840" y="3246120"/>
+            <a:off x="1005840" y="1691640"/>
             <a:ext cx="502920" cy="502920"/>
           </a:xfrm>
           <a:prstGeom prst="rect">
@@ -2719,13 +2159,13 @@
       </p:pic>
       <p:sp>
         <p:nvSpPr>
-          <p:cNvPr id="18" name="Text 13"/>
-          <p:cNvSpPr/>
-          <p:nvPr/>
-        </p:nvSpPr>
-        <p:spPr>
-          <a:xfrm>
-            <a:off x="1645920" y="3063240"/>
+          <p:cNvPr id="8" name="Text 5"/>
+          <p:cNvSpPr/>
+          <p:nvPr/>
+        </p:nvSpPr>
+        <p:spPr>
+          <a:xfrm>
+            <a:off x="1645920" y="1508760"/>
             <a:ext cx="2743200" cy="411480"/>
           </a:xfrm>
           <a:prstGeom prst="rect">
@@ -2738,7 +2178,7 @@
           <a:bodyPr wrap="square" lIns="0" tIns="0" rIns="0" bIns="0" rtlCol="0" anchor="ctr"/>
           <a:lstStyle/>
           <a:p>
-            <a:pPr indent="0" marL="0">
+            <a:pPr marL="0" indent="0">
               <a:buNone/>
             </a:pPr>
             <a:r>
@@ -2747,18 +2187,15 @@
                   <a:srgbClr val="FFFFFF"/>
                 </a:solidFill>
               </a:rPr>
-              <a:t>Order Flow</a:t>
-            </a:r>
-            <a:pPr indent="0" marL="0">
-              <a:buNone/>
-            </a:pPr>
+              <a:t>Technical</a:t>
+            </a:r>
             <a:r>
               <a:rPr lang="en-US" sz="2000" b="1" dirty="0">
                 <a:solidFill>
-                  <a:srgbClr val="A29BFE"/>
-                </a:solidFill>
-              </a:rPr>
-              <a:t>  20%</a:t>
+                  <a:srgbClr val="FFE66D"/>
+                </a:solidFill>
+              </a:rPr>
+              <a:t>  40%</a:t>
             </a:r>
             <a:endParaRPr lang="en-US" sz="1600" dirty="0"/>
           </a:p>
@@ -2766,13 +2203,13 @@
       </p:sp>
       <p:sp>
         <p:nvSpPr>
-          <p:cNvPr id="19" name="Text 14"/>
-          <p:cNvSpPr/>
-          <p:nvPr/>
-        </p:nvSpPr>
-        <p:spPr>
-          <a:xfrm>
-            <a:off x="1645920" y="3520440"/>
+          <p:cNvPr id="9" name="Text 6"/>
+          <p:cNvSpPr/>
+          <p:nvPr/>
+        </p:nvSpPr>
+        <p:spPr>
+          <a:xfrm>
+            <a:off x="1645920" y="1965960"/>
             <a:ext cx="2743200" cy="548640"/>
           </a:xfrm>
           <a:prstGeom prst="rect">
@@ -2785,7 +2222,7 @@
           <a:bodyPr wrap="square" lIns="0" tIns="0" rIns="0" bIns="0" rtlCol="0" anchor="ctr"/>
           <a:lstStyle/>
           <a:p>
-            <a:pPr indent="0" marL="0">
+            <a:pPr marL="0" indent="0">
               <a:buNone/>
             </a:pPr>
             <a:r>
@@ -2794,12 +2231,12 @@
                   <a:srgbClr val="8B8BA3"/>
                 </a:solidFill>
               </a:rPr>
-              <a:t>Polymarket buy/sell pressure</a:t>
+              <a:t>RSI mean-reversion at extremes</a:t>
             </a:r>
             <a:endParaRPr lang="en-US" sz="1100" dirty="0"/>
           </a:p>
           <a:p>
-            <a:pPr indent="0" marL="0">
+            <a:pPr marL="0" indent="0">
               <a:buNone/>
             </a:pPr>
             <a:r>
@@ -2808,7 +2245,7 @@
                   <a:srgbClr val="8B8BA3"/>
                 </a:solidFill>
               </a:rPr>
-              <a:t>True Markets order history</a:t>
+              <a:t>MACD trend direction</a:t>
             </a:r>
             <a:endParaRPr lang="en-US" sz="1100" dirty="0"/>
           </a:p>
@@ -2816,13 +2253,13 @@
       </p:sp>
       <p:sp>
         <p:nvSpPr>
-          <p:cNvPr id="20" name="Shape 15"/>
-          <p:cNvSpPr/>
-          <p:nvPr/>
-        </p:nvSpPr>
-        <p:spPr>
-          <a:xfrm>
-            <a:off x="4754880" y="2926080"/>
+          <p:cNvPr id="10" name="Shape 7"/>
+          <p:cNvSpPr/>
+          <p:nvPr/>
+        </p:nvSpPr>
+        <p:spPr>
+          <a:xfrm>
+            <a:off x="4754880" y="1371600"/>
             <a:ext cx="3840480" cy="1280160"/>
           </a:xfrm>
           <a:prstGeom prst="rect">
@@ -2836,27 +2273,27 @@
       </p:sp>
       <p:sp>
         <p:nvSpPr>
-          <p:cNvPr id="21" name="Shape 16"/>
-          <p:cNvSpPr/>
-          <p:nvPr/>
-        </p:nvSpPr>
-        <p:spPr>
-          <a:xfrm>
-            <a:off x="4754880" y="2926080"/>
+          <p:cNvPr id="11" name="Shape 8"/>
+          <p:cNvSpPr/>
+          <p:nvPr/>
+        </p:nvSpPr>
+        <p:spPr>
+          <a:xfrm>
+            <a:off x="4754880" y="1371600"/>
             <a:ext cx="54864" cy="1280160"/>
           </a:xfrm>
           <a:prstGeom prst="rect">
             <a:avLst/>
           </a:prstGeom>
           <a:solidFill>
-            <a:srgbClr val="4ECDC4"/>
+            <a:srgbClr val="00D4AA"/>
           </a:solidFill>
           <a:ln/>
         </p:spPr>
       </p:sp>
       <p:pic>
         <p:nvPicPr>
-          <p:cNvPr id="22" name="Image 3" descr="preencoded.png">    </p:cNvPr>
+          <p:cNvPr id="12" name="Image 1" descr="preencoded.png"/>
           <p:cNvPicPr>
             <a:picLocks noChangeAspect="1"/>
           </p:cNvPicPr>
@@ -2870,6 +2307,322 @@
         </p:blipFill>
         <p:spPr>
           <a:xfrm>
+            <a:off x="5029200" y="1691640"/>
+            <a:ext cx="502920" cy="502920"/>
+          </a:xfrm>
+          <a:prstGeom prst="rect">
+            <a:avLst/>
+          </a:prstGeom>
+        </p:spPr>
+      </p:pic>
+      <p:sp>
+        <p:nvSpPr>
+          <p:cNvPr id="13" name="Text 9"/>
+          <p:cNvSpPr/>
+          <p:nvPr/>
+        </p:nvSpPr>
+        <p:spPr>
+          <a:xfrm>
+            <a:off x="5669280" y="1508760"/>
+            <a:ext cx="2743200" cy="411480"/>
+          </a:xfrm>
+          <a:prstGeom prst="rect">
+            <a:avLst/>
+          </a:prstGeom>
+          <a:noFill/>
+          <a:ln/>
+        </p:spPr>
+        <p:txBody>
+          <a:bodyPr wrap="square" lIns="0" tIns="0" rIns="0" bIns="0" rtlCol="0" anchor="ctr"/>
+          <a:lstStyle/>
+          <a:p>
+            <a:pPr marL="0" indent="0">
+              <a:buNone/>
+            </a:pPr>
+            <a:r>
+              <a:rPr lang="en-US" sz="1600" b="1" dirty="0">
+                <a:solidFill>
+                  <a:srgbClr val="FFFFFF"/>
+                </a:solidFill>
+              </a:rPr>
+              <a:t>TCN Model</a:t>
+            </a:r>
+            <a:r>
+              <a:rPr lang="en-US" sz="2000" b="1" dirty="0">
+                <a:solidFill>
+                  <a:srgbClr val="00D4AA"/>
+                </a:solidFill>
+              </a:rPr>
+              <a:t>  30%</a:t>
+            </a:r>
+            <a:endParaRPr lang="en-US" sz="1600" dirty="0"/>
+          </a:p>
+        </p:txBody>
+      </p:sp>
+      <p:sp>
+        <p:nvSpPr>
+          <p:cNvPr id="14" name="Text 10"/>
+          <p:cNvSpPr/>
+          <p:nvPr/>
+        </p:nvSpPr>
+        <p:spPr>
+          <a:xfrm>
+            <a:off x="5669280" y="1965960"/>
+            <a:ext cx="2743200" cy="548640"/>
+          </a:xfrm>
+          <a:prstGeom prst="rect">
+            <a:avLst/>
+          </a:prstGeom>
+          <a:noFill/>
+          <a:ln/>
+        </p:spPr>
+        <p:txBody>
+          <a:bodyPr wrap="square" lIns="0" tIns="0" rIns="0" bIns="0" rtlCol="0" anchor="ctr"/>
+          <a:lstStyle/>
+          <a:p>
+            <a:pPr marL="0" indent="0">
+              <a:buNone/>
+            </a:pPr>
+            <a:r>
+              <a:rPr lang="en-US" sz="1100" dirty="0">
+                <a:solidFill>
+                  <a:srgbClr val="8B8BA3"/>
+                </a:solidFill>
+              </a:rPr>
+              <a:t>Temporal Convolutional Network</a:t>
+            </a:r>
+            <a:endParaRPr lang="en-US" sz="1100" dirty="0"/>
+          </a:p>
+          <a:p>
+            <a:pPr marL="0" indent="0">
+              <a:buNone/>
+            </a:pPr>
+            <a:r>
+              <a:rPr lang="en-US" sz="1100" dirty="0">
+                <a:solidFill>
+                  <a:srgbClr val="8B8BA3"/>
+                </a:solidFill>
+              </a:rPr>
+              <a:t>3 years of BTC training data</a:t>
+            </a:r>
+            <a:endParaRPr lang="en-US" sz="1100" dirty="0"/>
+          </a:p>
+        </p:txBody>
+      </p:sp>
+      <p:sp>
+        <p:nvSpPr>
+          <p:cNvPr id="15" name="Shape 11"/>
+          <p:cNvSpPr/>
+          <p:nvPr/>
+        </p:nvSpPr>
+        <p:spPr>
+          <a:xfrm>
+            <a:off x="731520" y="2926080"/>
+            <a:ext cx="3840480" cy="1280160"/>
+          </a:xfrm>
+          <a:prstGeom prst="rect">
+            <a:avLst/>
+          </a:prstGeom>
+          <a:solidFill>
+            <a:srgbClr val="1E1E36"/>
+          </a:solidFill>
+          <a:ln/>
+        </p:spPr>
+      </p:sp>
+      <p:sp>
+        <p:nvSpPr>
+          <p:cNvPr id="16" name="Shape 12"/>
+          <p:cNvSpPr/>
+          <p:nvPr/>
+        </p:nvSpPr>
+        <p:spPr>
+          <a:xfrm>
+            <a:off x="731520" y="2926080"/>
+            <a:ext cx="54864" cy="1280160"/>
+          </a:xfrm>
+          <a:prstGeom prst="rect">
+            <a:avLst/>
+          </a:prstGeom>
+          <a:solidFill>
+            <a:srgbClr val="A29BFE"/>
+          </a:solidFill>
+          <a:ln/>
+        </p:spPr>
+      </p:sp>
+      <p:pic>
+        <p:nvPicPr>
+          <p:cNvPr id="17" name="Image 2" descr="preencoded.png"/>
+          <p:cNvPicPr>
+            <a:picLocks noChangeAspect="1"/>
+          </p:cNvPicPr>
+          <p:nvPr/>
+        </p:nvPicPr>
+        <p:blipFill>
+          <a:blip r:embed="rId5"/>
+          <a:stretch>
+            <a:fillRect/>
+          </a:stretch>
+        </p:blipFill>
+        <p:spPr>
+          <a:xfrm>
+            <a:off x="1005840" y="3246120"/>
+            <a:ext cx="502920" cy="502920"/>
+          </a:xfrm>
+          <a:prstGeom prst="rect">
+            <a:avLst/>
+          </a:prstGeom>
+        </p:spPr>
+      </p:pic>
+      <p:sp>
+        <p:nvSpPr>
+          <p:cNvPr id="18" name="Text 13"/>
+          <p:cNvSpPr/>
+          <p:nvPr/>
+        </p:nvSpPr>
+        <p:spPr>
+          <a:xfrm>
+            <a:off x="1645920" y="3063240"/>
+            <a:ext cx="2743200" cy="411480"/>
+          </a:xfrm>
+          <a:prstGeom prst="rect">
+            <a:avLst/>
+          </a:prstGeom>
+          <a:noFill/>
+          <a:ln/>
+        </p:spPr>
+        <p:txBody>
+          <a:bodyPr wrap="square" lIns="0" tIns="0" rIns="0" bIns="0" rtlCol="0" anchor="ctr"/>
+          <a:lstStyle/>
+          <a:p>
+            <a:pPr marL="0" indent="0">
+              <a:buNone/>
+            </a:pPr>
+            <a:r>
+              <a:rPr lang="en-US" sz="1600" b="1" dirty="0">
+                <a:solidFill>
+                  <a:srgbClr val="FFFFFF"/>
+                </a:solidFill>
+              </a:rPr>
+              <a:t>Order Flow</a:t>
+            </a:r>
+            <a:r>
+              <a:rPr lang="en-US" sz="2000" b="1" dirty="0">
+                <a:solidFill>
+                  <a:srgbClr val="A29BFE"/>
+                </a:solidFill>
+              </a:rPr>
+              <a:t>  20%</a:t>
+            </a:r>
+            <a:endParaRPr lang="en-US" sz="1600" dirty="0"/>
+          </a:p>
+        </p:txBody>
+      </p:sp>
+      <p:sp>
+        <p:nvSpPr>
+          <p:cNvPr id="19" name="Text 14"/>
+          <p:cNvSpPr/>
+          <p:nvPr/>
+        </p:nvSpPr>
+        <p:spPr>
+          <a:xfrm>
+            <a:off x="1645920" y="3520440"/>
+            <a:ext cx="2743200" cy="548640"/>
+          </a:xfrm>
+          <a:prstGeom prst="rect">
+            <a:avLst/>
+          </a:prstGeom>
+          <a:noFill/>
+          <a:ln/>
+        </p:spPr>
+        <p:txBody>
+          <a:bodyPr wrap="square" lIns="0" tIns="0" rIns="0" bIns="0" rtlCol="0" anchor="ctr"/>
+          <a:lstStyle/>
+          <a:p>
+            <a:pPr marL="0" indent="0">
+              <a:buNone/>
+            </a:pPr>
+            <a:r>
+              <a:rPr lang="en-US" sz="1100" dirty="0">
+                <a:solidFill>
+                  <a:srgbClr val="8B8BA3"/>
+                </a:solidFill>
+              </a:rPr>
+              <a:t>Polymarket buy/sell pressure</a:t>
+            </a:r>
+            <a:endParaRPr lang="en-US" sz="1100" dirty="0"/>
+          </a:p>
+          <a:p>
+            <a:pPr marL="0" indent="0">
+              <a:buNone/>
+            </a:pPr>
+            <a:r>
+              <a:rPr lang="en-US" sz="1100" dirty="0">
+                <a:solidFill>
+                  <a:srgbClr val="8B8BA3"/>
+                </a:solidFill>
+              </a:rPr>
+              <a:t>True Markets order history</a:t>
+            </a:r>
+            <a:endParaRPr lang="en-US" sz="1100" dirty="0"/>
+          </a:p>
+        </p:txBody>
+      </p:sp>
+      <p:sp>
+        <p:nvSpPr>
+          <p:cNvPr id="20" name="Shape 15"/>
+          <p:cNvSpPr/>
+          <p:nvPr/>
+        </p:nvSpPr>
+        <p:spPr>
+          <a:xfrm>
+            <a:off x="4754880" y="2926080"/>
+            <a:ext cx="3840480" cy="1280160"/>
+          </a:xfrm>
+          <a:prstGeom prst="rect">
+            <a:avLst/>
+          </a:prstGeom>
+          <a:solidFill>
+            <a:srgbClr val="1E1E36"/>
+          </a:solidFill>
+          <a:ln/>
+        </p:spPr>
+      </p:sp>
+      <p:sp>
+        <p:nvSpPr>
+          <p:cNvPr id="21" name="Shape 16"/>
+          <p:cNvSpPr/>
+          <p:nvPr/>
+        </p:nvSpPr>
+        <p:spPr>
+          <a:xfrm>
+            <a:off x="4754880" y="2926080"/>
+            <a:ext cx="54864" cy="1280160"/>
+          </a:xfrm>
+          <a:prstGeom prst="rect">
+            <a:avLst/>
+          </a:prstGeom>
+          <a:solidFill>
+            <a:srgbClr val="4ECDC4"/>
+          </a:solidFill>
+          <a:ln/>
+        </p:spPr>
+      </p:sp>
+      <p:pic>
+        <p:nvPicPr>
+          <p:cNvPr id="22" name="Image 3" descr="preencoded.png"/>
+          <p:cNvPicPr>
+            <a:picLocks noChangeAspect="1"/>
+          </p:cNvPicPr>
+          <p:nvPr/>
+        </p:nvPicPr>
+        <p:blipFill>
+          <a:blip r:embed="rId6"/>
+          <a:stretch>
+            <a:fillRect/>
+          </a:stretch>
+        </p:blipFill>
+        <p:spPr>
+          <a:xfrm>
             <a:off x="5029200" y="3246120"/>
             <a:ext cx="502920" cy="502920"/>
           </a:xfrm>
@@ -2899,7 +2652,7 @@
           <a:bodyPr wrap="square" lIns="0" tIns="0" rIns="0" bIns="0" rtlCol="0" anchor="ctr"/>
           <a:lstStyle/>
           <a:p>
-            <a:pPr indent="0" marL="0">
+            <a:pPr marL="0" indent="0">
               <a:buNone/>
             </a:pPr>
             <a:r>
@@ -2910,9 +2663,6 @@
               </a:rPr>
               <a:t>Sentiment</a:t>
             </a:r>
-            <a:pPr indent="0" marL="0">
-              <a:buNone/>
-            </a:pPr>
             <a:r>
               <a:rPr lang="en-US" sz="2000" b="1" dirty="0">
                 <a:solidFill>
@@ -2946,7 +2696,7 @@
           <a:bodyPr wrap="square" lIns="0" tIns="0" rIns="0" bIns="0" rtlCol="0" anchor="ctr"/>
           <a:lstStyle/>
           <a:p>
-            <a:pPr indent="0" marL="0">
+            <a:pPr marL="0" indent="0">
               <a:buNone/>
             </a:pPr>
             <a:r>
@@ -2960,7 +2710,7 @@
             <a:endParaRPr lang="en-US" sz="1100" dirty="0"/>
           </a:p>
           <a:p>
-            <a:pPr indent="0" marL="0">
+            <a:pPr marL="0" indent="0">
               <a:buNone/>
             </a:pPr>
             <a:r>
@@ -2996,7 +2746,7 @@
           <a:bodyPr wrap="square" lIns="0" tIns="0" rIns="0" bIns="0" rtlCol="0" anchor="ctr"/>
           <a:lstStyle/>
           <a:p>
-            <a:pPr algn="ctr" indent="0" marL="0">
+            <a:pPr marL="0" indent="0" algn="ctr">
               <a:buNone/>
             </a:pPr>
             <a:r>
@@ -3030,6 +2780,7 @@
         <a:solidFill>
           <a:srgbClr val="0F0F1A"/>
         </a:solidFill>
+        <a:effectLst/>
       </p:bgPr>
     </p:bg>
     <p:spTree>
@@ -3087,7 +2838,7 @@
           <a:bodyPr wrap="square" lIns="0" tIns="0" rIns="0" bIns="0" rtlCol="0" anchor="ctr"/>
           <a:lstStyle/>
           <a:p>
-            <a:pPr indent="0" marL="0">
+            <a:pPr marL="0" indent="0">
               <a:buNone/>
             </a:pPr>
             <a:r>
@@ -3146,7 +2897,7 @@
           <a:bodyPr wrap="square" lIns="0" tIns="0" rIns="0" bIns="0" rtlCol="0" anchor="ctr"/>
           <a:lstStyle/>
           <a:p>
-            <a:pPr algn="ctr" indent="0" marL="0">
+            <a:pPr marL="0" indent="0" algn="ctr">
               <a:buNone/>
             </a:pPr>
             <a:r>
@@ -3185,7 +2936,7 @@
           <a:bodyPr wrap="square" lIns="0" tIns="0" rIns="0" bIns="0" rtlCol="0" anchor="ctr"/>
           <a:lstStyle/>
           <a:p>
-            <a:pPr algn="ctr" indent="0" marL="0">
+            <a:pPr marL="0" indent="0" algn="ctr">
               <a:buNone/>
             </a:pPr>
             <a:r>
@@ -3199,7 +2950,7 @@
             <a:endParaRPr lang="en-US" sz="1200" dirty="0"/>
           </a:p>
           <a:p>
-            <a:pPr algn="ctr" indent="0" marL="0">
+            <a:pPr marL="0" indent="0" algn="ctr">
               <a:buNone/>
             </a:pPr>
             <a:r>
@@ -3255,7 +3006,7 @@
           <a:bodyPr wrap="square" lIns="0" tIns="0" rIns="0" bIns="0" rtlCol="0" anchor="ctr"/>
           <a:lstStyle/>
           <a:p>
-            <a:pPr algn="ctr" indent="0" marL="0">
+            <a:pPr marL="0" indent="0" algn="ctr">
               <a:buNone/>
             </a:pPr>
             <a:r>
@@ -3294,7 +3045,7 @@
           <a:bodyPr wrap="square" lIns="0" tIns="0" rIns="0" bIns="0" rtlCol="0" anchor="ctr"/>
           <a:lstStyle/>
           <a:p>
-            <a:pPr algn="ctr" indent="0" marL="0">
+            <a:pPr marL="0" indent="0" algn="ctr">
               <a:buNone/>
             </a:pPr>
             <a:r>
@@ -3308,7 +3059,7 @@
             <a:endParaRPr lang="en-US" sz="1200" dirty="0"/>
           </a:p>
           <a:p>
-            <a:pPr algn="ctr" indent="0" marL="0">
+            <a:pPr marL="0" indent="0" algn="ctr">
               <a:buNone/>
             </a:pPr>
             <a:r>
@@ -3364,7 +3115,7 @@
           <a:bodyPr wrap="square" lIns="0" tIns="0" rIns="0" bIns="0" rtlCol="0" anchor="ctr"/>
           <a:lstStyle/>
           <a:p>
-            <a:pPr algn="ctr" indent="0" marL="0">
+            <a:pPr marL="0" indent="0" algn="ctr">
               <a:buNone/>
             </a:pPr>
             <a:r>
@@ -3403,7 +3154,7 @@
           <a:bodyPr wrap="square" lIns="0" tIns="0" rIns="0" bIns="0" rtlCol="0" anchor="ctr"/>
           <a:lstStyle/>
           <a:p>
-            <a:pPr algn="ctr" indent="0" marL="0">
+            <a:pPr marL="0" indent="0" algn="ctr">
               <a:buNone/>
             </a:pPr>
             <a:r>
@@ -3417,7 +3168,7 @@
             <a:endParaRPr lang="en-US" sz="1200" dirty="0"/>
           </a:p>
           <a:p>
-            <a:pPr algn="ctr" indent="0" marL="0">
+            <a:pPr marL="0" indent="0" algn="ctr">
               <a:buNone/>
             </a:pPr>
             <a:r>
@@ -3473,7 +3224,7 @@
           <a:bodyPr wrap="square" lIns="0" tIns="0" rIns="0" bIns="0" rtlCol="0" anchor="ctr"/>
           <a:lstStyle/>
           <a:p>
-            <a:pPr indent="0" marL="0">
+            <a:pPr marL="0" indent="0">
               <a:buNone/>
             </a:pPr>
             <a:r>
@@ -3529,7 +3280,7 @@
           <a:bodyPr wrap="square" lIns="0" tIns="0" rIns="0" bIns="0" rtlCol="0" anchor="ctr"/>
           <a:lstStyle/>
           <a:p>
-            <a:pPr indent="0" marL="0">
+            <a:pPr marL="0" indent="0">
               <a:buNone/>
             </a:pPr>
             <a:r>
@@ -3585,7 +3336,7 @@
           <a:bodyPr wrap="square" lIns="0" tIns="0" rIns="0" bIns="0" rtlCol="0" anchor="ctr"/>
           <a:lstStyle/>
           <a:p>
-            <a:pPr indent="0" marL="0">
+            <a:pPr marL="0" indent="0">
               <a:buNone/>
             </a:pPr>
             <a:r>
@@ -3641,7 +3392,7 @@
           <a:bodyPr wrap="square" lIns="0" tIns="0" rIns="0" bIns="0" rtlCol="0" anchor="ctr"/>
           <a:lstStyle/>
           <a:p>
-            <a:pPr indent="0" marL="0">
+            <a:pPr marL="0" indent="0">
               <a:buNone/>
             </a:pPr>
             <a:r>
@@ -3697,7 +3448,7 @@
           <a:bodyPr wrap="square" lIns="0" tIns="0" rIns="0" bIns="0" rtlCol="0" anchor="ctr"/>
           <a:lstStyle/>
           <a:p>
-            <a:pPr indent="0" marL="0">
+            <a:pPr marL="0" indent="0">
               <a:buNone/>
             </a:pPr>
             <a:r>
@@ -3753,7 +3504,7 @@
           <a:bodyPr wrap="square" lIns="0" tIns="0" rIns="0" bIns="0" rtlCol="0" anchor="ctr"/>
           <a:lstStyle/>
           <a:p>
-            <a:pPr indent="0" marL="0">
+            <a:pPr marL="0" indent="0">
               <a:buNone/>
             </a:pPr>
             <a:r>
@@ -3789,7 +3540,7 @@
           <a:bodyPr wrap="square" lIns="0" tIns="0" rIns="0" bIns="0" rtlCol="0" anchor="ctr"/>
           <a:lstStyle/>
           <a:p>
-            <a:pPr indent="0" marL="0">
+            <a:pPr marL="0" indent="0">
               <a:buNone/>
             </a:pPr>
             <a:r>
@@ -3823,6 +3574,7 @@
         <a:solidFill>
           <a:srgbClr val="0F0F1A"/>
         </a:solidFill>
+        <a:effectLst/>
       </p:bgPr>
     </p:bg>
     <p:spTree>
@@ -3861,55 +3613,7 @@
       </p:sp>
       <p:pic>
         <p:nvPicPr>
-          <p:cNvPr id="3" name="Image 0" descr="/Users/saieshagupta/Desktop/claude/truemarkets-predictions/backend/backtest_results/yc_accuracy.png">    </p:cNvPr>
-          <p:cNvPicPr>
-            <a:picLocks noChangeAspect="1"/>
-          </p:cNvPicPr>
-          <p:nvPr/>
-        </p:nvPicPr>
-        <p:blipFill>
-          <a:blip r:embed="rId1"/>
-          <a:stretch>
-            <a:fillRect/>
-          </a:stretch>
-        </p:blipFill>
-        <p:spPr>
-          <a:xfrm>
-            <a:off x="274320" y="137160"/>
-            <a:ext cx="4572000" cy="2514600"/>
-          </a:xfrm>
-          <a:prstGeom prst="rect">
-            <a:avLst/>
-          </a:prstGeom>
-        </p:spPr>
-      </p:pic>
-      <p:pic>
-        <p:nvPicPr>
-          <p:cNvPr id="4" name="Image 1" descr="/Users/saieshagupta/Desktop/claude/truemarkets-predictions/backend/backtest_results/yc_consensus.png">    </p:cNvPr>
-          <p:cNvPicPr>
-            <a:picLocks noChangeAspect="1"/>
-          </p:cNvPicPr>
-          <p:nvPr/>
-        </p:nvPicPr>
-        <p:blipFill>
-          <a:blip r:embed="rId2"/>
-          <a:stretch>
-            <a:fillRect/>
-          </a:stretch>
-        </p:blipFill>
-        <p:spPr>
-          <a:xfrm>
-            <a:off x="4572000" y="137160"/>
-            <a:ext cx="4389120" cy="2514600"/>
-          </a:xfrm>
-          <a:prstGeom prst="rect">
-            <a:avLst/>
-          </a:prstGeom>
-        </p:spPr>
-      </p:pic>
-      <p:pic>
-        <p:nvPicPr>
-          <p:cNvPr id="5" name="Image 2" descr="/Users/saieshagupta/Desktop/claude/truemarkets-predictions/backend/backtest_results/yc_returns.png">    </p:cNvPr>
+          <p:cNvPr id="3" name="Image 0" descr="/Users/saieshagupta/Desktop/claude/truemarkets-predictions/backend/backtest_results/yc_accuracy.png"/>
           <p:cNvPicPr>
             <a:picLocks noChangeAspect="1"/>
           </p:cNvPicPr>
@@ -3923,8 +3627,56 @@
         </p:blipFill>
         <p:spPr>
           <a:xfrm>
+            <a:off x="274320" y="137160"/>
+            <a:ext cx="4572000" cy="2514600"/>
+          </a:xfrm>
+          <a:prstGeom prst="rect">
+            <a:avLst/>
+          </a:prstGeom>
+        </p:spPr>
+      </p:pic>
+      <p:pic>
+        <p:nvPicPr>
+          <p:cNvPr id="4" name="Image 1" descr="/Users/saieshagupta/Desktop/claude/truemarkets-predictions/backend/backtest_results/yc_consensus.png"/>
+          <p:cNvPicPr>
+            <a:picLocks noChangeAspect="1"/>
+          </p:cNvPicPr>
+          <p:nvPr/>
+        </p:nvPicPr>
+        <p:blipFill>
+          <a:blip r:embed="rId4"/>
+          <a:stretch>
+            <a:fillRect/>
+          </a:stretch>
+        </p:blipFill>
+        <p:spPr>
+          <a:xfrm>
+            <a:off x="4572000" y="137160"/>
+            <a:ext cx="4389120" cy="2514600"/>
+          </a:xfrm>
+          <a:prstGeom prst="rect">
+            <a:avLst/>
+          </a:prstGeom>
+        </p:spPr>
+      </p:pic>
+      <p:pic>
+        <p:nvPicPr>
+          <p:cNvPr id="5" name="Image 2" descr="/Users/saieshagupta/Desktop/claude/truemarkets-predictions/backend/backtest_results/yc_returns.png"/>
+          <p:cNvPicPr>
+            <a:picLocks noChangeAspect="1"/>
+          </p:cNvPicPr>
+          <p:nvPr/>
+        </p:nvPicPr>
+        <p:blipFill>
+          <a:blip r:embed="rId5"/>
+          <a:stretch>
+            <a:fillRect/>
+          </a:stretch>
+        </p:blipFill>
+        <p:spPr>
+          <a:xfrm>
             <a:off x="274320" y="2743200"/>
-            <a:ext cx="8595360" cy="2286000"/>
+            <a:ext cx="4572000" cy="2286000"/>
           </a:xfrm>
           <a:prstGeom prst="rect">
             <a:avLst/>
@@ -3947,6 +3699,7 @@
         <a:solidFill>
           <a:srgbClr val="0F0F1A"/>
         </a:solidFill>
+        <a:effectLst/>
       </p:bgPr>
     </p:bg>
     <p:spTree>
@@ -4004,7 +3757,7 @@
           <a:bodyPr wrap="square" lIns="0" tIns="0" rIns="0" bIns="0" rtlCol="0" anchor="ctr"/>
           <a:lstStyle/>
           <a:p>
-            <a:pPr indent="0" marL="0">
+            <a:pPr marL="0" indent="0">
               <a:buNone/>
             </a:pPr>
             <a:r>
@@ -4043,7 +3796,7 @@
           <a:bodyPr wrap="square" lIns="0" tIns="0" rIns="0" bIns="0" rtlCol="0" anchor="ctr"/>
           <a:lstStyle/>
           <a:p>
-            <a:pPr indent="0" marL="0">
+            <a:pPr marL="0" indent="0">
               <a:buNone/>
             </a:pPr>
             <a:r>
@@ -4060,127 +3813,7 @@
       </p:sp>
       <p:pic>
         <p:nvPicPr>
-          <p:cNvPr id="5" name="Image 0" descr="preencoded.png">    </p:cNvPr>
-          <p:cNvPicPr>
-            <a:picLocks noChangeAspect="1"/>
-          </p:cNvPicPr>
-          <p:nvPr/>
-        </p:nvPicPr>
-        <p:blipFill>
-          <a:blip r:embed="rId1"/>
-          <a:stretch>
-            <a:fillRect/>
-          </a:stretch>
-        </p:blipFill>
-        <p:spPr>
-          <a:xfrm>
-            <a:off x="914400" y="1371600"/>
-            <a:ext cx="320040" cy="320040"/>
-          </a:xfrm>
-          <a:prstGeom prst="rect">
-            <a:avLst/>
-          </a:prstGeom>
-        </p:spPr>
-      </p:pic>
-      <p:sp>
-        <p:nvSpPr>
-          <p:cNvPr id="6" name="Text 3"/>
-          <p:cNvSpPr/>
-          <p:nvPr/>
-        </p:nvSpPr>
-        <p:spPr>
-          <a:xfrm>
-            <a:off x="1417320" y="1353312"/>
-            <a:ext cx="3657600" cy="365760"/>
-          </a:xfrm>
-          <a:prstGeom prst="rect">
-            <a:avLst/>
-          </a:prstGeom>
-          <a:noFill/>
-          <a:ln/>
-        </p:spPr>
-        <p:txBody>
-          <a:bodyPr wrap="square" lIns="0" tIns="0" rIns="0" bIns="0" rtlCol="0" anchor="ctr"/>
-          <a:lstStyle/>
-          <a:p>
-            <a:pPr indent="0" marL="0">
-              <a:buNone/>
-            </a:pPr>
-            <a:r>
-              <a:rPr lang="en-US" sz="1300" dirty="0">
-                <a:solidFill>
-                  <a:srgbClr val="FFFFFF"/>
-                </a:solidFill>
-              </a:rPr>
-              <a:t>Real-time BTC price from True Markets API</a:t>
-            </a:r>
-            <a:endParaRPr lang="en-US" sz="1300" dirty="0"/>
-          </a:p>
-        </p:txBody>
-      </p:sp>
-      <p:pic>
-        <p:nvPicPr>
-          <p:cNvPr id="7" name="Image 1" descr="preencoded.png">    </p:cNvPr>
-          <p:cNvPicPr>
-            <a:picLocks noChangeAspect="1"/>
-          </p:cNvPicPr>
-          <p:nvPr/>
-        </p:nvPicPr>
-        <p:blipFill>
-          <a:blip r:embed="rId2"/>
-          <a:stretch>
-            <a:fillRect/>
-          </a:stretch>
-        </p:blipFill>
-        <p:spPr>
-          <a:xfrm>
-            <a:off x="914400" y="2011680"/>
-            <a:ext cx="320040" cy="320040"/>
-          </a:xfrm>
-          <a:prstGeom prst="rect">
-            <a:avLst/>
-          </a:prstGeom>
-        </p:spPr>
-      </p:pic>
-      <p:sp>
-        <p:nvSpPr>
-          <p:cNvPr id="8" name="Text 4"/>
-          <p:cNvSpPr/>
-          <p:nvPr/>
-        </p:nvSpPr>
-        <p:spPr>
-          <a:xfrm>
-            <a:off x="1417320" y="1993392"/>
-            <a:ext cx="3657600" cy="365760"/>
-          </a:xfrm>
-          <a:prstGeom prst="rect">
-            <a:avLst/>
-          </a:prstGeom>
-          <a:noFill/>
-          <a:ln/>
-        </p:spPr>
-        <p:txBody>
-          <a:bodyPr wrap="square" lIns="0" tIns="0" rIns="0" bIns="0" rtlCol="0" anchor="ctr"/>
-          <a:lstStyle/>
-          <a:p>
-            <a:pPr indent="0" marL="0">
-              <a:buNone/>
-            </a:pPr>
-            <a:r>
-              <a:rPr lang="en-US" sz="1300" dirty="0">
-                <a:solidFill>
-                  <a:srgbClr val="FFFFFF"/>
-                </a:solidFill>
-              </a:rPr>
-              <a:t>Auto-refreshing TCN predictions every 30s</a:t>
-            </a:r>
-            <a:endParaRPr lang="en-US" sz="1300" dirty="0"/>
-          </a:p>
-        </p:txBody>
-      </p:sp>
-      <p:pic>
-        <p:nvPicPr>
-          <p:cNvPr id="9" name="Image 2" descr="preencoded.png">    </p:cNvPr>
+          <p:cNvPr id="5" name="Image 0" descr="preencoded.png"/>
           <p:cNvPicPr>
             <a:picLocks noChangeAspect="1"/>
           </p:cNvPicPr>
@@ -4194,7 +3827,7 @@
         </p:blipFill>
         <p:spPr>
           <a:xfrm>
-            <a:off x="914400" y="2651760"/>
+            <a:off x="914400" y="1371600"/>
             <a:ext cx="320040" cy="320040"/>
           </a:xfrm>
           <a:prstGeom prst="rect">
@@ -4204,13 +3837,13 @@
       </p:pic>
       <p:sp>
         <p:nvSpPr>
-          <p:cNvPr id="10" name="Text 5"/>
-          <p:cNvSpPr/>
-          <p:nvPr/>
-        </p:nvSpPr>
-        <p:spPr>
-          <a:xfrm>
-            <a:off x="1417320" y="2633472"/>
+          <p:cNvPr id="6" name="Text 3"/>
+          <p:cNvSpPr/>
+          <p:nvPr/>
+        </p:nvSpPr>
+        <p:spPr>
+          <a:xfrm>
+            <a:off x="1417320" y="1353312"/>
             <a:ext cx="3657600" cy="365760"/>
           </a:xfrm>
           <a:prstGeom prst="rect">
@@ -4223,7 +3856,7 @@
           <a:bodyPr wrap="square" lIns="0" tIns="0" rIns="0" bIns="0" rtlCol="0" anchor="ctr"/>
           <a:lstStyle/>
           <a:p>
-            <a:pPr indent="0" marL="0">
+            <a:pPr marL="0" indent="0">
               <a:buNone/>
             </a:pPr>
             <a:r>
@@ -4232,7 +3865,7 @@
                   <a:srgbClr val="FFFFFF"/>
                 </a:solidFill>
               </a:rPr>
-              <a:t>Polymarket mispricing detection</a:t>
+              <a:t>Real-time BTC price from True Markets API</a:t>
             </a:r>
             <a:endParaRPr lang="en-US" sz="1300" dirty="0"/>
           </a:p>
@@ -4240,7 +3873,7 @@
       </p:sp>
       <p:pic>
         <p:nvPicPr>
-          <p:cNvPr id="11" name="Image 3" descr="preencoded.png">    </p:cNvPr>
+          <p:cNvPr id="7" name="Image 1" descr="preencoded.png"/>
           <p:cNvPicPr>
             <a:picLocks noChangeAspect="1"/>
           </p:cNvPicPr>
@@ -4254,7 +3887,7 @@
         </p:blipFill>
         <p:spPr>
           <a:xfrm>
-            <a:off x="914400" y="3291840"/>
+            <a:off x="914400" y="2011680"/>
             <a:ext cx="320040" cy="320040"/>
           </a:xfrm>
           <a:prstGeom prst="rect">
@@ -4264,13 +3897,13 @@
       </p:pic>
       <p:sp>
         <p:nvSpPr>
-          <p:cNvPr id="12" name="Text 6"/>
-          <p:cNvSpPr/>
-          <p:nvPr/>
-        </p:nvSpPr>
-        <p:spPr>
-          <a:xfrm>
-            <a:off x="1417320" y="3273552"/>
+          <p:cNvPr id="8" name="Text 4"/>
+          <p:cNvSpPr/>
+          <p:nvPr/>
+        </p:nvSpPr>
+        <p:spPr>
+          <a:xfrm>
+            <a:off x="1417320" y="1993392"/>
             <a:ext cx="3657600" cy="365760"/>
           </a:xfrm>
           <a:prstGeom prst="rect">
@@ -4283,7 +3916,7 @@
           <a:bodyPr wrap="square" lIns="0" tIns="0" rIns="0" bIns="0" rtlCol="0" anchor="ctr"/>
           <a:lstStyle/>
           <a:p>
-            <a:pPr indent="0" marL="0">
+            <a:pPr marL="0" indent="0">
               <a:buNone/>
             </a:pPr>
             <a:r>
@@ -4292,74 +3925,15 @@
                   <a:srgbClr val="FFFFFF"/>
                 </a:solidFill>
               </a:rPr>
-              <a:t>Clear BUY/SELL with signal-by-signal reasoning</a:t>
+              <a:t>Auto-refreshing TCN predictions every 30s</a:t>
             </a:r>
             <a:endParaRPr lang="en-US" sz="1300" dirty="0"/>
-          </a:p>
-        </p:txBody>
-      </p:sp>
-      <p:sp>
-        <p:nvSpPr>
-          <p:cNvPr id="13" name="Shape 7"/>
-          <p:cNvSpPr/>
-          <p:nvPr/>
-        </p:nvSpPr>
-        <p:spPr>
-          <a:xfrm>
-            <a:off x="5303520" y="1188720"/>
-            <a:ext cx="3474720" cy="2560320"/>
-          </a:xfrm>
-          <a:prstGeom prst="rect">
-            <a:avLst/>
-          </a:prstGeom>
-          <a:solidFill>
-            <a:srgbClr val="1E1E36"/>
-          </a:solidFill>
-          <a:ln/>
-        </p:spPr>
-      </p:sp>
-      <p:sp>
-        <p:nvSpPr>
-          <p:cNvPr id="14" name="Text 8"/>
-          <p:cNvSpPr/>
-          <p:nvPr/>
-        </p:nvSpPr>
-        <p:spPr>
-          <a:xfrm>
-            <a:off x="5577840" y="1325880"/>
-            <a:ext cx="2926080" cy="365760"/>
-          </a:xfrm>
-          <a:prstGeom prst="rect">
-            <a:avLst/>
-          </a:prstGeom>
-          <a:noFill/>
-          <a:ln/>
-        </p:spPr>
-        <p:txBody>
-          <a:bodyPr wrap="square" lIns="0" tIns="0" rIns="0" bIns="0" rtlCol="0" anchor="ctr"/>
-          <a:lstStyle/>
-          <a:p>
-            <a:pPr indent="0" marL="0">
-              <a:buNone/>
-            </a:pPr>
-            <a:r>
-              <a:rPr lang="en-US" sz="1800" b="1" dirty="0">
-                <a:solidFill>
-                  <a:srgbClr val="00D4AA"/>
-                </a:solidFill>
-                <a:latin typeface="Calibri" pitchFamily="34" charset="0"/>
-                <a:ea typeface="Calibri" pitchFamily="34" charset="-122"/>
-                <a:cs typeface="Calibri" pitchFamily="34" charset="-120"/>
-              </a:rPr>
-              <a:t>What’s Next</a:t>
-            </a:r>
-            <a:endParaRPr lang="en-US" sz="1800" dirty="0"/>
           </a:p>
         </p:txBody>
       </p:sp>
       <p:pic>
         <p:nvPicPr>
-          <p:cNvPr id="15" name="Image 4" descr="preencoded.png">    </p:cNvPr>
+          <p:cNvPr id="9" name="Image 2" descr="preencoded.png"/>
           <p:cNvPicPr>
             <a:picLocks noChangeAspect="1"/>
           </p:cNvPicPr>
@@ -4373,8 +3947,8 @@
         </p:blipFill>
         <p:spPr>
           <a:xfrm>
-            <a:off x="5669280" y="1920240"/>
-            <a:ext cx="274320" cy="274320"/>
+            <a:off x="914400" y="2651760"/>
+            <a:ext cx="320040" cy="320040"/>
           </a:xfrm>
           <a:prstGeom prst="rect">
             <a:avLst/>
@@ -4383,43 +3957,43 @@
       </p:pic>
       <p:sp>
         <p:nvSpPr>
-          <p:cNvPr id="16" name="Text 9"/>
-          <p:cNvSpPr/>
-          <p:nvPr/>
-        </p:nvSpPr>
-        <p:spPr>
-          <a:xfrm>
-            <a:off x="6126480" y="1901952"/>
-            <a:ext cx="2468880" cy="320040"/>
-          </a:xfrm>
-          <a:prstGeom prst="rect">
-            <a:avLst/>
-          </a:prstGeom>
-          <a:noFill/>
-          <a:ln/>
-        </p:spPr>
-        <p:txBody>
-          <a:bodyPr wrap="square" lIns="0" tIns="0" rIns="0" bIns="0" rtlCol="0" anchor="ctr"/>
-          <a:lstStyle/>
-          <a:p>
-            <a:pPr indent="0" marL="0">
-              <a:buNone/>
-            </a:pPr>
-            <a:r>
-              <a:rPr lang="en-US" sz="1200" dirty="0">
-                <a:solidFill>
-                  <a:srgbClr val="8B8BA3"/>
-                </a:solidFill>
-              </a:rPr>
-              <a:t>Multi-coin (ETH, SOL configured)</a:t>
-            </a:r>
-            <a:endParaRPr lang="en-US" sz="1200" dirty="0"/>
+          <p:cNvPr id="10" name="Text 5"/>
+          <p:cNvSpPr/>
+          <p:nvPr/>
+        </p:nvSpPr>
+        <p:spPr>
+          <a:xfrm>
+            <a:off x="1417320" y="2633472"/>
+            <a:ext cx="3657600" cy="365760"/>
+          </a:xfrm>
+          <a:prstGeom prst="rect">
+            <a:avLst/>
+          </a:prstGeom>
+          <a:noFill/>
+          <a:ln/>
+        </p:spPr>
+        <p:txBody>
+          <a:bodyPr wrap="square" lIns="0" tIns="0" rIns="0" bIns="0" rtlCol="0" anchor="ctr"/>
+          <a:lstStyle/>
+          <a:p>
+            <a:pPr marL="0" indent="0">
+              <a:buNone/>
+            </a:pPr>
+            <a:r>
+              <a:rPr lang="en-US" sz="1300" dirty="0">
+                <a:solidFill>
+                  <a:srgbClr val="FFFFFF"/>
+                </a:solidFill>
+              </a:rPr>
+              <a:t>Polymarket mispricing detection</a:t>
+            </a:r>
+            <a:endParaRPr lang="en-US" sz="1300" dirty="0"/>
           </a:p>
         </p:txBody>
       </p:sp>
       <p:pic>
         <p:nvPicPr>
-          <p:cNvPr id="17" name="Image 5" descr="preencoded.png">    </p:cNvPr>
+          <p:cNvPr id="11" name="Image 3" descr="preencoded.png"/>
           <p:cNvPicPr>
             <a:picLocks noChangeAspect="1"/>
           </p:cNvPicPr>
@@ -4433,8 +4007,8 @@
         </p:blipFill>
         <p:spPr>
           <a:xfrm>
-            <a:off x="5669280" y="2468880"/>
-            <a:ext cx="274320" cy="274320"/>
+            <a:off x="914400" y="3291840"/>
+            <a:ext cx="320040" cy="320040"/>
           </a:xfrm>
           <a:prstGeom prst="rect">
             <a:avLst/>
@@ -4443,43 +4017,102 @@
       </p:pic>
       <p:sp>
         <p:nvSpPr>
-          <p:cNvPr id="18" name="Text 10"/>
-          <p:cNvSpPr/>
-          <p:nvPr/>
-        </p:nvSpPr>
-        <p:spPr>
-          <a:xfrm>
-            <a:off x="6126480" y="2450592"/>
-            <a:ext cx="2468880" cy="320040"/>
-          </a:xfrm>
-          <a:prstGeom prst="rect">
-            <a:avLst/>
-          </a:prstGeom>
-          <a:noFill/>
-          <a:ln/>
-        </p:spPr>
-        <p:txBody>
-          <a:bodyPr wrap="square" lIns="0" tIns="0" rIns="0" bIns="0" rtlCol="0" anchor="ctr"/>
-          <a:lstStyle/>
-          <a:p>
-            <a:pPr indent="0" marL="0">
-              <a:buNone/>
-            </a:pPr>
-            <a:r>
-              <a:rPr lang="en-US" sz="1200" dirty="0">
-                <a:solidFill>
-                  <a:srgbClr val="8B8BA3"/>
-                </a:solidFill>
-              </a:rPr>
-              <a:t>Trading via True Markets Gateway</a:t>
-            </a:r>
-            <a:endParaRPr lang="en-US" sz="1200" dirty="0"/>
+          <p:cNvPr id="12" name="Text 6"/>
+          <p:cNvSpPr/>
+          <p:nvPr/>
+        </p:nvSpPr>
+        <p:spPr>
+          <a:xfrm>
+            <a:off x="1417320" y="3273552"/>
+            <a:ext cx="3657600" cy="365760"/>
+          </a:xfrm>
+          <a:prstGeom prst="rect">
+            <a:avLst/>
+          </a:prstGeom>
+          <a:noFill/>
+          <a:ln/>
+        </p:spPr>
+        <p:txBody>
+          <a:bodyPr wrap="square" lIns="0" tIns="0" rIns="0" bIns="0" rtlCol="0" anchor="ctr"/>
+          <a:lstStyle/>
+          <a:p>
+            <a:pPr marL="0" indent="0">
+              <a:buNone/>
+            </a:pPr>
+            <a:r>
+              <a:rPr lang="en-US" sz="1300" dirty="0">
+                <a:solidFill>
+                  <a:srgbClr val="FFFFFF"/>
+                </a:solidFill>
+              </a:rPr>
+              <a:t>Clear BUY/SELL with signal-by-signal reasoning</a:t>
+            </a:r>
+            <a:endParaRPr lang="en-US" sz="1300" dirty="0"/>
+          </a:p>
+        </p:txBody>
+      </p:sp>
+      <p:sp>
+        <p:nvSpPr>
+          <p:cNvPr id="13" name="Shape 7"/>
+          <p:cNvSpPr/>
+          <p:nvPr/>
+        </p:nvSpPr>
+        <p:spPr>
+          <a:xfrm>
+            <a:off x="5303520" y="1188720"/>
+            <a:ext cx="3474720" cy="2560320"/>
+          </a:xfrm>
+          <a:prstGeom prst="rect">
+            <a:avLst/>
+          </a:prstGeom>
+          <a:solidFill>
+            <a:srgbClr val="1E1E36"/>
+          </a:solidFill>
+          <a:ln/>
+        </p:spPr>
+      </p:sp>
+      <p:sp>
+        <p:nvSpPr>
+          <p:cNvPr id="14" name="Text 8"/>
+          <p:cNvSpPr/>
+          <p:nvPr/>
+        </p:nvSpPr>
+        <p:spPr>
+          <a:xfrm>
+            <a:off x="5577840" y="1325880"/>
+            <a:ext cx="2926080" cy="365760"/>
+          </a:xfrm>
+          <a:prstGeom prst="rect">
+            <a:avLst/>
+          </a:prstGeom>
+          <a:noFill/>
+          <a:ln/>
+        </p:spPr>
+        <p:txBody>
+          <a:bodyPr wrap="square" lIns="0" tIns="0" rIns="0" bIns="0" rtlCol="0" anchor="ctr"/>
+          <a:lstStyle/>
+          <a:p>
+            <a:pPr marL="0" indent="0">
+              <a:buNone/>
+            </a:pPr>
+            <a:r>
+              <a:rPr lang="en-US" sz="1800" b="1" dirty="0">
+                <a:solidFill>
+                  <a:srgbClr val="00D4AA"/>
+                </a:solidFill>
+                <a:latin typeface="Calibri" pitchFamily="34" charset="0"/>
+                <a:ea typeface="Calibri" pitchFamily="34" charset="-122"/>
+                <a:cs typeface="Calibri" pitchFamily="34" charset="-120"/>
+              </a:rPr>
+              <a:t>What’s Next</a:t>
+            </a:r>
+            <a:endParaRPr lang="en-US" sz="1800" dirty="0"/>
           </a:p>
         </p:txBody>
       </p:sp>
       <p:pic>
         <p:nvPicPr>
-          <p:cNvPr id="19" name="Image 6" descr="preencoded.png">    </p:cNvPr>
+          <p:cNvPr id="15" name="Image 4" descr="preencoded.png"/>
           <p:cNvPicPr>
             <a:picLocks noChangeAspect="1"/>
           </p:cNvPicPr>
@@ -4493,6 +4126,126 @@
         </p:blipFill>
         <p:spPr>
           <a:xfrm>
+            <a:off x="5669280" y="1920240"/>
+            <a:ext cx="274320" cy="274320"/>
+          </a:xfrm>
+          <a:prstGeom prst="rect">
+            <a:avLst/>
+          </a:prstGeom>
+        </p:spPr>
+      </p:pic>
+      <p:sp>
+        <p:nvSpPr>
+          <p:cNvPr id="16" name="Text 9"/>
+          <p:cNvSpPr/>
+          <p:nvPr/>
+        </p:nvSpPr>
+        <p:spPr>
+          <a:xfrm>
+            <a:off x="6126480" y="1901952"/>
+            <a:ext cx="2468880" cy="320040"/>
+          </a:xfrm>
+          <a:prstGeom prst="rect">
+            <a:avLst/>
+          </a:prstGeom>
+          <a:noFill/>
+          <a:ln/>
+        </p:spPr>
+        <p:txBody>
+          <a:bodyPr wrap="square" lIns="0" tIns="0" rIns="0" bIns="0" rtlCol="0" anchor="ctr"/>
+          <a:lstStyle/>
+          <a:p>
+            <a:pPr marL="0" indent="0">
+              <a:buNone/>
+            </a:pPr>
+            <a:r>
+              <a:rPr lang="en-US" sz="1200" dirty="0">
+                <a:solidFill>
+                  <a:srgbClr val="8B8BA3"/>
+                </a:solidFill>
+              </a:rPr>
+              <a:t>Multi-coin (ETH, SOL configured)</a:t>
+            </a:r>
+            <a:endParaRPr lang="en-US" sz="1200" dirty="0"/>
+          </a:p>
+        </p:txBody>
+      </p:sp>
+      <p:pic>
+        <p:nvPicPr>
+          <p:cNvPr id="17" name="Image 5" descr="preencoded.png"/>
+          <p:cNvPicPr>
+            <a:picLocks noChangeAspect="1"/>
+          </p:cNvPicPr>
+          <p:nvPr/>
+        </p:nvPicPr>
+        <p:blipFill>
+          <a:blip r:embed="rId8"/>
+          <a:stretch>
+            <a:fillRect/>
+          </a:stretch>
+        </p:blipFill>
+        <p:spPr>
+          <a:xfrm>
+            <a:off x="5669280" y="2468880"/>
+            <a:ext cx="274320" cy="274320"/>
+          </a:xfrm>
+          <a:prstGeom prst="rect">
+            <a:avLst/>
+          </a:prstGeom>
+        </p:spPr>
+      </p:pic>
+      <p:sp>
+        <p:nvSpPr>
+          <p:cNvPr id="18" name="Text 10"/>
+          <p:cNvSpPr/>
+          <p:nvPr/>
+        </p:nvSpPr>
+        <p:spPr>
+          <a:xfrm>
+            <a:off x="6126480" y="2450592"/>
+            <a:ext cx="2468880" cy="320040"/>
+          </a:xfrm>
+          <a:prstGeom prst="rect">
+            <a:avLst/>
+          </a:prstGeom>
+          <a:noFill/>
+          <a:ln/>
+        </p:spPr>
+        <p:txBody>
+          <a:bodyPr wrap="square" lIns="0" tIns="0" rIns="0" bIns="0" rtlCol="0" anchor="ctr"/>
+          <a:lstStyle/>
+          <a:p>
+            <a:pPr marL="0" indent="0">
+              <a:buNone/>
+            </a:pPr>
+            <a:r>
+              <a:rPr lang="en-US" sz="1200" dirty="0">
+                <a:solidFill>
+                  <a:srgbClr val="8B8BA3"/>
+                </a:solidFill>
+              </a:rPr>
+              <a:t>Trading via True Markets Gateway</a:t>
+            </a:r>
+            <a:endParaRPr lang="en-US" sz="1200" dirty="0"/>
+          </a:p>
+        </p:txBody>
+      </p:sp>
+      <p:pic>
+        <p:nvPicPr>
+          <p:cNvPr id="19" name="Image 6" descr="preencoded.png"/>
+          <p:cNvPicPr>
+            <a:picLocks noChangeAspect="1"/>
+          </p:cNvPicPr>
+          <p:nvPr/>
+        </p:nvPicPr>
+        <p:blipFill>
+          <a:blip r:embed="rId9"/>
+          <a:stretch>
+            <a:fillRect/>
+          </a:stretch>
+        </p:blipFill>
+        <p:spPr>
+          <a:xfrm>
             <a:off x="5669280" y="3017520"/>
             <a:ext cx="274320" cy="274320"/>
           </a:xfrm>
@@ -4522,7 +4275,7 @@
           <a:bodyPr wrap="square" lIns="0" tIns="0" rIns="0" bIns="0" rtlCol="0" anchor="ctr"/>
           <a:lstStyle/>
           <a:p>
-            <a:pPr indent="0" marL="0">
+            <a:pPr marL="0" indent="0">
               <a:buNone/>
             </a:pPr>
             <a:r>
@@ -4578,7 +4331,7 @@
           <a:bodyPr wrap="square" lIns="0" tIns="0" rIns="0" bIns="0" rtlCol="0" anchor="ctr"/>
           <a:lstStyle/>
           <a:p>
-            <a:pPr algn="ctr" indent="0" marL="0">
+            <a:pPr marL="0" indent="0" algn="ctr">
               <a:buNone/>
             </a:pPr>
             <a:r>
@@ -4617,7 +4370,7 @@
           <a:bodyPr wrap="square" lIns="0" tIns="0" rIns="0" bIns="0" rtlCol="0" anchor="ctr"/>
           <a:lstStyle/>
           <a:p>
-            <a:pPr algn="ctr" indent="0" marL="0">
+            <a:pPr marL="0" indent="0" algn="ctr">
               <a:buNone/>
             </a:pPr>
             <a:r>
@@ -4933,4 +4686,299 @@
     </a:ext>
   </a:extLst>
 </a:theme>
+</file>
+
+<file path=ppt/theme/theme2.xml><?xml version="1.0" encoding="utf-8"?>
+<a:theme xmlns:a="http://schemas.openxmlformats.org/drawingml/2006/main" name="Office Theme">
+  <a:themeElements>
+    <a:clrScheme name="Office">
+      <a:dk1>
+        <a:sysClr val="windowText" lastClr="000000"/>
+      </a:dk1>
+      <a:lt1>
+        <a:sysClr val="window" lastClr="FFFFFF"/>
+      </a:lt1>
+      <a:dk2>
+        <a:srgbClr val="44546A"/>
+      </a:dk2>
+      <a:lt2>
+        <a:srgbClr val="E7E6E6"/>
+      </a:lt2>
+      <a:accent1>
+        <a:srgbClr val="4472C4"/>
+      </a:accent1>
+      <a:accent2>
+        <a:srgbClr val="ED7D31"/>
+      </a:accent2>
+      <a:accent3>
+        <a:srgbClr val="A5A5A5"/>
+      </a:accent3>
+      <a:accent4>
+        <a:srgbClr val="FFC000"/>
+      </a:accent4>
+      <a:accent5>
+        <a:srgbClr val="5B9BD5"/>
+      </a:accent5>
+      <a:accent6>
+        <a:srgbClr val="70AD47"/>
+      </a:accent6>
+      <a:hlink>
+        <a:srgbClr val="0563C1"/>
+      </a:hlink>
+      <a:folHlink>
+        <a:srgbClr val="954F72"/>
+      </a:folHlink>
+    </a:clrScheme>
+    <a:fontScheme name="Office">
+      <a:majorFont>
+        <a:latin typeface="Calibri Light" panose="020F0302020204030204"/>
+        <a:ea typeface=""/>
+        <a:cs typeface=""/>
+        <a:font script="Jpan" typeface="游ゴシック Light"/>
+        <a:font script="Hang" typeface="맑은 고딕"/>
+        <a:font script="Hans" typeface="等线 Light"/>
+        <a:font script="Hant" typeface="新細明體"/>
+        <a:font script="Arab" typeface="Times New Roman"/>
+        <a:font script="Hebr" typeface="Times New Roman"/>
+        <a:font script="Thai" typeface="Angsana New"/>
+        <a:font script="Ethi" typeface="Nyala"/>
+        <a:font script="Beng" typeface="Vrinda"/>
+        <a:font script="Gujr" typeface="Shruti"/>
+        <a:font script="Khmr" typeface="MoolBoran"/>
+        <a:font script="Knda" typeface="Tunga"/>
+        <a:font script="Guru" typeface="Raavi"/>
+        <a:font script="Cans" typeface="Euphemia"/>
+        <a:font script="Cher" typeface="Plantagenet Cherokee"/>
+        <a:font script="Yiii" typeface="Microsoft Yi Baiti"/>
+        <a:font script="Tibt" typeface="Microsoft Himalaya"/>
+        <a:font script="Thaa" typeface="MV Boli"/>
+        <a:font script="Deva" typeface="Mangal"/>
+        <a:font script="Telu" typeface="Gautami"/>
+        <a:font script="Taml" typeface="Latha"/>
+        <a:font script="Syrc" typeface="Estrangelo Edessa"/>
+        <a:font script="Orya" typeface="Kalinga"/>
+        <a:font script="Mlym" typeface="Kartika"/>
+        <a:font script="Laoo" typeface="DokChampa"/>
+        <a:font script="Sinh" typeface="Iskoola Pota"/>
+        <a:font script="Mong" typeface="Mongolian Baiti"/>
+        <a:font script="Viet" typeface="Times New Roman"/>
+        <a:font script="Uigh" typeface="Microsoft Uighur"/>
+        <a:font script="Geor" typeface="Sylfaen"/>
+        <a:font script="Armn" typeface="Arial"/>
+        <a:font script="Bugi" typeface="Leelawadee UI"/>
+        <a:font script="Bopo" typeface="Microsoft JhengHei"/>
+        <a:font script="Java" typeface="Javanese Text"/>
+        <a:font script="Lisu" typeface="Segoe UI"/>
+        <a:font script="Mymr" typeface="Myanmar Text"/>
+        <a:font script="Nkoo" typeface="Ebrima"/>
+        <a:font script="Olck" typeface="Nirmala UI"/>
+        <a:font script="Osma" typeface="Ebrima"/>
+        <a:font script="Phag" typeface="Phagspa"/>
+        <a:font script="Syrn" typeface="Estrangelo Edessa"/>
+        <a:font script="Syrj" typeface="Estrangelo Edessa"/>
+        <a:font script="Syre" typeface="Estrangelo Edessa"/>
+        <a:font script="Sora" typeface="Nirmala UI"/>
+        <a:font script="Tale" typeface="Microsoft Tai Le"/>
+        <a:font script="Talu" typeface="Microsoft New Tai Lue"/>
+        <a:font script="Tfng" typeface="Ebrima"/>
+      </a:majorFont>
+      <a:minorFont>
+        <a:latin typeface="Calibri" panose="020F0502020204030204"/>
+        <a:ea typeface=""/>
+        <a:cs typeface=""/>
+        <a:font script="Jpan" typeface="游ゴシック"/>
+        <a:font script="Hang" typeface="맑은 고딕"/>
+        <a:font script="Hans" typeface="等线"/>
+        <a:font script="Hant" typeface="新細明體"/>
+        <a:font script="Arab" typeface="Arial"/>
+        <a:font script="Hebr" typeface="Arial"/>
+        <a:font script="Thai" typeface="Cordia New"/>
+        <a:font script="Ethi" typeface="Nyala"/>
+        <a:font script="Beng" typeface="Vrinda"/>
+        <a:font script="Gujr" typeface="Shruti"/>
+        <a:font script="Khmr" typeface="DaunPenh"/>
+        <a:font script="Knda" typeface="Tunga"/>
+        <a:font script="Guru" typeface="Raavi"/>
+        <a:font script="Cans" typeface="Euphemia"/>
+        <a:font script="Cher" typeface="Plantagenet Cherokee"/>
+        <a:font script="Yiii" typeface="Microsoft Yi Baiti"/>
+        <a:font script="Tibt" typeface="Microsoft Himalaya"/>
+        <a:font script="Thaa" typeface="MV Boli"/>
+        <a:font script="Deva" typeface="Mangal"/>
+        <a:font script="Telu" typeface="Gautami"/>
+        <a:font script="Taml" typeface="Latha"/>
+        <a:font script="Syrc" typeface="Estrangelo Edessa"/>
+        <a:font script="Orya" typeface="Kalinga"/>
+        <a:font script="Mlym" typeface="Kartika"/>
+        <a:font script="Laoo" typeface="DokChampa"/>
+        <a:font script="Sinh" typeface="Iskoola Pota"/>
+        <a:font script="Mong" typeface="Mongolian Baiti"/>
+        <a:font script="Viet" typeface="Arial"/>
+        <a:font script="Uigh" typeface="Microsoft Uighur"/>
+        <a:font script="Geor" typeface="Sylfaen"/>
+        <a:font script="Armn" typeface="Arial"/>
+        <a:font script="Bugi" typeface="Leelawadee UI"/>
+        <a:font script="Bopo" typeface="Microsoft JhengHei"/>
+        <a:font script="Java" typeface="Javanese Text"/>
+        <a:font script="Lisu" typeface="Segoe UI"/>
+        <a:font script="Mymr" typeface="Myanmar Text"/>
+        <a:font script="Nkoo" typeface="Ebrima"/>
+        <a:font script="Olck" typeface="Nirmala UI"/>
+        <a:font script="Osma" typeface="Ebrima"/>
+        <a:font script="Phag" typeface="Phagspa"/>
+        <a:font script="Syrn" typeface="Estrangelo Edessa"/>
+        <a:font script="Syrj" typeface="Estrangelo Edessa"/>
+        <a:font script="Syre" typeface="Estrangelo Edessa"/>
+        <a:font script="Sora" typeface="Nirmala UI"/>
+        <a:font script="Tale" typeface="Microsoft Tai Le"/>
+        <a:font script="Talu" typeface="Microsoft New Tai Lue"/>
+        <a:font script="Tfng" typeface="Ebrima"/>
+      </a:minorFont>
+    </a:fontScheme>
+    <a:fmtScheme name="Office">
+      <a:fillStyleLst>
+        <a:solidFill>
+          <a:schemeClr val="phClr"/>
+        </a:solidFill>
+        <a:gradFill rotWithShape="1">
+          <a:gsLst>
+            <a:gs pos="0">
+              <a:schemeClr val="phClr">
+                <a:lumMod val="110000"/>
+                <a:satMod val="105000"/>
+                <a:tint val="67000"/>
+              </a:schemeClr>
+            </a:gs>
+            <a:gs pos="50000">
+              <a:schemeClr val="phClr">
+                <a:lumMod val="105000"/>
+                <a:satMod val="103000"/>
+                <a:tint val="73000"/>
+              </a:schemeClr>
+            </a:gs>
+            <a:gs pos="100000">
+              <a:schemeClr val="phClr">
+                <a:lumMod val="105000"/>
+                <a:satMod val="109000"/>
+                <a:tint val="81000"/>
+              </a:schemeClr>
+            </a:gs>
+          </a:gsLst>
+          <a:lin ang="5400000" scaled="0"/>
+        </a:gradFill>
+        <a:gradFill rotWithShape="1">
+          <a:gsLst>
+            <a:gs pos="0">
+              <a:schemeClr val="phClr">
+                <a:satMod val="103000"/>
+                <a:lumMod val="102000"/>
+                <a:tint val="94000"/>
+              </a:schemeClr>
+            </a:gs>
+            <a:gs pos="50000">
+              <a:schemeClr val="phClr">
+                <a:satMod val="110000"/>
+                <a:lumMod val="100000"/>
+                <a:shade val="100000"/>
+              </a:schemeClr>
+            </a:gs>
+            <a:gs pos="100000">
+              <a:schemeClr val="phClr">
+                <a:lumMod val="99000"/>
+                <a:satMod val="120000"/>
+                <a:shade val="78000"/>
+              </a:schemeClr>
+            </a:gs>
+          </a:gsLst>
+          <a:lin ang="5400000" scaled="0"/>
+        </a:gradFill>
+      </a:fillStyleLst>
+      <a:lnStyleLst>
+        <a:ln w="6350" cap="flat" cmpd="sng" algn="ctr">
+          <a:solidFill>
+            <a:schemeClr val="phClr"/>
+          </a:solidFill>
+          <a:prstDash val="solid"/>
+          <a:miter lim="800000"/>
+        </a:ln>
+        <a:ln w="12700" cap="flat" cmpd="sng" algn="ctr">
+          <a:solidFill>
+            <a:schemeClr val="phClr"/>
+          </a:solidFill>
+          <a:prstDash val="solid"/>
+          <a:miter lim="800000"/>
+        </a:ln>
+        <a:ln w="19050" cap="flat" cmpd="sng" algn="ctr">
+          <a:solidFill>
+            <a:schemeClr val="phClr"/>
+          </a:solidFill>
+          <a:prstDash val="solid"/>
+          <a:miter lim="800000"/>
+        </a:ln>
+      </a:lnStyleLst>
+      <a:effectStyleLst>
+        <a:effectStyle>
+          <a:effectLst/>
+        </a:effectStyle>
+        <a:effectStyle>
+          <a:effectLst/>
+        </a:effectStyle>
+        <a:effectStyle>
+          <a:effectLst>
+            <a:outerShdw blurRad="57150" dist="19050" dir="5400000" algn="ctr" rotWithShape="0">
+              <a:srgbClr val="000000">
+                <a:alpha val="63000"/>
+              </a:srgbClr>
+            </a:outerShdw>
+          </a:effectLst>
+        </a:effectStyle>
+      </a:effectStyleLst>
+      <a:bgFillStyleLst>
+        <a:solidFill>
+          <a:schemeClr val="phClr"/>
+        </a:solidFill>
+        <a:solidFill>
+          <a:schemeClr val="phClr">
+            <a:tint val="95000"/>
+            <a:satMod val="170000"/>
+          </a:schemeClr>
+        </a:solidFill>
+        <a:gradFill rotWithShape="1">
+          <a:gsLst>
+            <a:gs pos="0">
+              <a:schemeClr val="phClr">
+                <a:tint val="93000"/>
+                <a:satMod val="150000"/>
+                <a:shade val="98000"/>
+                <a:lumMod val="102000"/>
+              </a:schemeClr>
+            </a:gs>
+            <a:gs pos="50000">
+              <a:schemeClr val="phClr">
+                <a:tint val="98000"/>
+                <a:satMod val="130000"/>
+                <a:shade val="90000"/>
+                <a:lumMod val="103000"/>
+              </a:schemeClr>
+            </a:gs>
+            <a:gs pos="100000">
+              <a:schemeClr val="phClr">
+                <a:shade val="63000"/>
+                <a:satMod val="120000"/>
+              </a:schemeClr>
+            </a:gs>
+          </a:gsLst>
+          <a:lin ang="5400000" scaled="0"/>
+        </a:gradFill>
+      </a:bgFillStyleLst>
+    </a:fmtScheme>
+  </a:themeElements>
+  <a:objectDefaults/>
+  <a:extraClrSchemeLst/>
+  <a:extLst>
+    <a:ext uri="{05A4C25C-085E-4340-85A3-A5531E510DB2}">
+      <thm15:themeFamily xmlns:thm15="http://schemas.microsoft.com/office/thememl/2012/main" name="Office Theme" id="{62F939B6-93AF-4DB8-9C6B-D6C7DFDC589F}" vid="{4A3C46E8-61CC-4603-A589-7422A47A8E4A}"/>
+    </a:ext>
+  </a:extLst>
+</a:theme>
 </file>
</xml_diff>